<commit_message>
omg many change wowowowowow
</commit_message>
<xml_diff>
--- a/Project Hullraker Diagrams.pptx
+++ b/Project Hullraker Diagrams.pptx
@@ -6,8 +6,9 @@
   </p:sldMasterIdLst>
   <p:sldIdLst>
     <p:sldId id="256" r:id="rId2"/>
-    <p:sldId id="257" r:id="rId3"/>
-    <p:sldId id="258" r:id="rId4"/>
+    <p:sldId id="259" r:id="rId3"/>
+    <p:sldId id="262" r:id="rId4"/>
+    <p:sldId id="258" r:id="rId5"/>
   </p:sldIdLst>
   <p:sldSz cx="12192000" cy="6858000"/>
   <p:notesSz cx="6858000" cy="9144000"/>
@@ -106,6 +107,11 @@
       </a:defRPr>
     </a:lvl9pPr>
   </p:defaultTextStyle>
+  <p:extLst>
+    <p:ext uri="{EFAFB233-063F-42B5-8137-9DF3F51BA10A}">
+      <p15:sldGuideLst xmlns:p15="http://schemas.microsoft.com/office/powerpoint/2012/main"/>
+    </p:ext>
+  </p:extLst>
 </p:presentation>
 </file>
 
@@ -256,7 +262,7 @@
           <a:p>
             <a:fld id="{BC88A4CC-0FCE-4549-B705-F62817C338D0}" type="datetimeFigureOut">
               <a:rPr lang="en-US" smtClean="0"/>
-              <a:t>1/1/2026</a:t>
+              <a:t>4/18/2026</a:t>
             </a:fld>
             <a:endParaRPr lang="en-US"/>
           </a:p>
@@ -454,7 +460,7 @@
           <a:p>
             <a:fld id="{BC88A4CC-0FCE-4549-B705-F62817C338D0}" type="datetimeFigureOut">
               <a:rPr lang="en-US" smtClean="0"/>
-              <a:t>1/1/2026</a:t>
+              <a:t>4/18/2026</a:t>
             </a:fld>
             <a:endParaRPr lang="en-US"/>
           </a:p>
@@ -662,7 +668,7 @@
           <a:p>
             <a:fld id="{BC88A4CC-0FCE-4549-B705-F62817C338D0}" type="datetimeFigureOut">
               <a:rPr lang="en-US" smtClean="0"/>
-              <a:t>1/1/2026</a:t>
+              <a:t>4/18/2026</a:t>
             </a:fld>
             <a:endParaRPr lang="en-US"/>
           </a:p>
@@ -860,7 +866,7 @@
           <a:p>
             <a:fld id="{BC88A4CC-0FCE-4549-B705-F62817C338D0}" type="datetimeFigureOut">
               <a:rPr lang="en-US" smtClean="0"/>
-              <a:t>1/1/2026</a:t>
+              <a:t>4/18/2026</a:t>
             </a:fld>
             <a:endParaRPr lang="en-US"/>
           </a:p>
@@ -1135,7 +1141,7 @@
           <a:p>
             <a:fld id="{BC88A4CC-0FCE-4549-B705-F62817C338D0}" type="datetimeFigureOut">
               <a:rPr lang="en-US" smtClean="0"/>
-              <a:t>1/1/2026</a:t>
+              <a:t>4/18/2026</a:t>
             </a:fld>
             <a:endParaRPr lang="en-US"/>
           </a:p>
@@ -1400,7 +1406,7 @@
           <a:p>
             <a:fld id="{BC88A4CC-0FCE-4549-B705-F62817C338D0}" type="datetimeFigureOut">
               <a:rPr lang="en-US" smtClean="0"/>
-              <a:t>1/1/2026</a:t>
+              <a:t>4/18/2026</a:t>
             </a:fld>
             <a:endParaRPr lang="en-US"/>
           </a:p>
@@ -1812,7 +1818,7 @@
           <a:p>
             <a:fld id="{BC88A4CC-0FCE-4549-B705-F62817C338D0}" type="datetimeFigureOut">
               <a:rPr lang="en-US" smtClean="0"/>
-              <a:t>1/1/2026</a:t>
+              <a:t>4/18/2026</a:t>
             </a:fld>
             <a:endParaRPr lang="en-US"/>
           </a:p>
@@ -1953,7 +1959,7 @@
           <a:p>
             <a:fld id="{BC88A4CC-0FCE-4549-B705-F62817C338D0}" type="datetimeFigureOut">
               <a:rPr lang="en-US" smtClean="0"/>
-              <a:t>1/1/2026</a:t>
+              <a:t>4/18/2026</a:t>
             </a:fld>
             <a:endParaRPr lang="en-US"/>
           </a:p>
@@ -2066,7 +2072,7 @@
           <a:p>
             <a:fld id="{BC88A4CC-0FCE-4549-B705-F62817C338D0}" type="datetimeFigureOut">
               <a:rPr lang="en-US" smtClean="0"/>
-              <a:t>1/1/2026</a:t>
+              <a:t>4/18/2026</a:t>
             </a:fld>
             <a:endParaRPr lang="en-US"/>
           </a:p>
@@ -2377,7 +2383,7 @@
           <a:p>
             <a:fld id="{BC88A4CC-0FCE-4549-B705-F62817C338D0}" type="datetimeFigureOut">
               <a:rPr lang="en-US" smtClean="0"/>
-              <a:t>1/1/2026</a:t>
+              <a:t>4/18/2026</a:t>
             </a:fld>
             <a:endParaRPr lang="en-US"/>
           </a:p>
@@ -2665,7 +2671,7 @@
           <a:p>
             <a:fld id="{BC88A4CC-0FCE-4549-B705-F62817C338D0}" type="datetimeFigureOut">
               <a:rPr lang="en-US" smtClean="0"/>
-              <a:t>1/1/2026</a:t>
+              <a:t>4/18/2026</a:t>
             </a:fld>
             <a:endParaRPr lang="en-US"/>
           </a:p>
@@ -2906,7 +2912,7 @@
           <a:p>
             <a:fld id="{BC88A4CC-0FCE-4549-B705-F62817C338D0}" type="datetimeFigureOut">
               <a:rPr lang="en-US" smtClean="0"/>
-              <a:t>1/1/2026</a:t>
+              <a:t>4/18/2026</a:t>
             </a:fld>
             <a:endParaRPr lang="en-US"/>
           </a:p>
@@ -3338,7 +3344,7 @@
           <p:nvPr>
             <p:extLst>
               <p:ext uri="{D42A27DB-BD31-4B8C-83A1-F6EECF244321}">
-                <p14:modId xmlns:p14="http://schemas.microsoft.com/office/powerpoint/2010/main" val="564319126"/>
+                <p14:modId xmlns:p14="http://schemas.microsoft.com/office/powerpoint/2010/main" val="607422074"/>
               </p:ext>
             </p:extLst>
           </p:nvPr>
@@ -3354,15 +3360,123 @@
                 <a:tableStyleId>{2D5ABB26-0587-4C30-8999-92F81FD0307C}</a:tableStyleId>
               </a:tblPr>
               <a:tblGrid>
-                <a:gridCol w="6720840">
+                <a:gridCol w="2240280">
                   <a:extLst>
                     <a:ext uri="{9D8B030D-6E8A-4147-A177-3AD203B41FA5}">
                       <a16:colId xmlns:a16="http://schemas.microsoft.com/office/drawing/2014/main" val="2115971656"/>
                     </a:ext>
                   </a:extLst>
                 </a:gridCol>
+                <a:gridCol w="2240280">
+                  <a:extLst>
+                    <a:ext uri="{9D8B030D-6E8A-4147-A177-3AD203B41FA5}">
+                      <a16:colId xmlns:a16="http://schemas.microsoft.com/office/drawing/2014/main" val="3167834644"/>
+                    </a:ext>
+                  </a:extLst>
+                </a:gridCol>
+                <a:gridCol w="2240280">
+                  <a:extLst>
+                    <a:ext uri="{9D8B030D-6E8A-4147-A177-3AD203B41FA5}">
+                      <a16:colId xmlns:a16="http://schemas.microsoft.com/office/drawing/2014/main" val="3390183887"/>
+                    </a:ext>
+                  </a:extLst>
+                </a:gridCol>
               </a:tblGrid>
               <a:tr h="1192378">
+                <a:tc>
+                  <a:txBody>
+                    <a:bodyPr/>
+                    <a:lstStyle/>
+                    <a:p>
+                      <a:endParaRPr lang="en-US" dirty="0"/>
+                    </a:p>
+                  </a:txBody>
+                  <a:tcPr>
+                    <a:lnL w="12700" cap="flat" cmpd="sng" algn="ctr">
+                      <a:solidFill>
+                        <a:schemeClr val="tx1"/>
+                      </a:solidFill>
+                      <a:prstDash val="solid"/>
+                      <a:round/>
+                      <a:headEnd type="none" w="med" len="med"/>
+                      <a:tailEnd type="none" w="med" len="med"/>
+                    </a:lnL>
+                    <a:lnR w="12700" cap="flat" cmpd="sng" algn="ctr">
+                      <a:solidFill>
+                        <a:schemeClr val="tx1"/>
+                      </a:solidFill>
+                      <a:prstDash val="solid"/>
+                      <a:round/>
+                      <a:headEnd type="none" w="med" len="med"/>
+                      <a:tailEnd type="none" w="med" len="med"/>
+                    </a:lnR>
+                    <a:lnT w="12700" cap="flat" cmpd="sng" algn="ctr">
+                      <a:solidFill>
+                        <a:schemeClr val="tx1"/>
+                      </a:solidFill>
+                      <a:prstDash val="solid"/>
+                      <a:round/>
+                      <a:headEnd type="none" w="med" len="med"/>
+                      <a:tailEnd type="none" w="med" len="med"/>
+                    </a:lnT>
+                    <a:lnB w="12700" cap="flat" cmpd="sng" algn="ctr">
+                      <a:solidFill>
+                        <a:schemeClr val="tx1"/>
+                      </a:solidFill>
+                      <a:prstDash val="solid"/>
+                      <a:round/>
+                      <a:headEnd type="none" w="med" len="med"/>
+                      <a:tailEnd type="none" w="med" len="med"/>
+                    </a:lnB>
+                  </a:tcPr>
+                </a:tc>
+                <a:tc>
+                  <a:txBody>
+                    <a:bodyPr/>
+                    <a:lstStyle/>
+                    <a:p>
+                      <a:endParaRPr lang="en-US" dirty="0"/>
+                    </a:p>
+                  </a:txBody>
+                  <a:tcPr>
+                    <a:lnL w="12700" cap="flat" cmpd="sng" algn="ctr">
+                      <a:solidFill>
+                        <a:schemeClr val="tx1"/>
+                      </a:solidFill>
+                      <a:prstDash val="solid"/>
+                      <a:round/>
+                      <a:headEnd type="none" w="med" len="med"/>
+                      <a:tailEnd type="none" w="med" len="med"/>
+                    </a:lnL>
+                    <a:lnR w="12700" cap="flat" cmpd="sng" algn="ctr">
+                      <a:solidFill>
+                        <a:schemeClr val="tx1"/>
+                      </a:solidFill>
+                      <a:prstDash val="solid"/>
+                      <a:round/>
+                      <a:headEnd type="none" w="med" len="med"/>
+                      <a:tailEnd type="none" w="med" len="med"/>
+                    </a:lnR>
+                    <a:lnT w="12700" cap="flat" cmpd="sng" algn="ctr">
+                      <a:solidFill>
+                        <a:schemeClr val="tx1"/>
+                      </a:solidFill>
+                      <a:prstDash val="solid"/>
+                      <a:round/>
+                      <a:headEnd type="none" w="med" len="med"/>
+                      <a:tailEnd type="none" w="med" len="med"/>
+                    </a:lnT>
+                    <a:lnB w="12700" cap="flat" cmpd="sng" algn="ctr">
+                      <a:solidFill>
+                        <a:schemeClr val="tx1"/>
+                      </a:solidFill>
+                      <a:prstDash val="solid"/>
+                      <a:round/>
+                      <a:headEnd type="none" w="med" len="med"/>
+                      <a:tailEnd type="none" w="med" len="med"/>
+                    </a:lnB>
+                  </a:tcPr>
+                </a:tc>
                 <a:tc>
                   <a:txBody>
                     <a:bodyPr/>
@@ -3464,6 +3578,100 @@
                     </a:lnB>
                   </a:tcPr>
                 </a:tc>
+                <a:tc>
+                  <a:txBody>
+                    <a:bodyPr/>
+                    <a:lstStyle/>
+                    <a:p>
+                      <a:endParaRPr lang="en-US" dirty="0"/>
+                    </a:p>
+                  </a:txBody>
+                  <a:tcPr>
+                    <a:lnL w="12700" cap="flat" cmpd="sng" algn="ctr">
+                      <a:solidFill>
+                        <a:schemeClr val="tx1"/>
+                      </a:solidFill>
+                      <a:prstDash val="solid"/>
+                      <a:round/>
+                      <a:headEnd type="none" w="med" len="med"/>
+                      <a:tailEnd type="none" w="med" len="med"/>
+                    </a:lnL>
+                    <a:lnR w="12700" cap="flat" cmpd="sng" algn="ctr">
+                      <a:solidFill>
+                        <a:schemeClr val="tx1"/>
+                      </a:solidFill>
+                      <a:prstDash val="solid"/>
+                      <a:round/>
+                      <a:headEnd type="none" w="med" len="med"/>
+                      <a:tailEnd type="none" w="med" len="med"/>
+                    </a:lnR>
+                    <a:lnT w="12700" cap="flat" cmpd="sng" algn="ctr">
+                      <a:solidFill>
+                        <a:schemeClr val="tx1"/>
+                      </a:solidFill>
+                      <a:prstDash val="solid"/>
+                      <a:round/>
+                      <a:headEnd type="none" w="med" len="med"/>
+                      <a:tailEnd type="none" w="med" len="med"/>
+                    </a:lnT>
+                    <a:lnB w="12700" cap="flat" cmpd="sng" algn="ctr">
+                      <a:solidFill>
+                        <a:schemeClr val="tx1"/>
+                      </a:solidFill>
+                      <a:prstDash val="solid"/>
+                      <a:round/>
+                      <a:headEnd type="none" w="med" len="med"/>
+                      <a:tailEnd type="none" w="med" len="med"/>
+                    </a:lnB>
+                  </a:tcPr>
+                </a:tc>
+                <a:tc>
+                  <a:txBody>
+                    <a:bodyPr/>
+                    <a:lstStyle/>
+                    <a:p>
+                      <a:endParaRPr lang="en-US" dirty="0"/>
+                    </a:p>
+                  </a:txBody>
+                  <a:tcPr>
+                    <a:lnL w="12700" cap="flat" cmpd="sng" algn="ctr">
+                      <a:solidFill>
+                        <a:schemeClr val="tx1"/>
+                      </a:solidFill>
+                      <a:prstDash val="solid"/>
+                      <a:round/>
+                      <a:headEnd type="none" w="med" len="med"/>
+                      <a:tailEnd type="none" w="med" len="med"/>
+                    </a:lnL>
+                    <a:lnR w="12700" cap="flat" cmpd="sng" algn="ctr">
+                      <a:solidFill>
+                        <a:schemeClr val="tx1"/>
+                      </a:solidFill>
+                      <a:prstDash val="solid"/>
+                      <a:round/>
+                      <a:headEnd type="none" w="med" len="med"/>
+                      <a:tailEnd type="none" w="med" len="med"/>
+                    </a:lnR>
+                    <a:lnT w="12700" cap="flat" cmpd="sng" algn="ctr">
+                      <a:solidFill>
+                        <a:schemeClr val="tx1"/>
+                      </a:solidFill>
+                      <a:prstDash val="solid"/>
+                      <a:round/>
+                      <a:headEnd type="none" w="med" len="med"/>
+                      <a:tailEnd type="none" w="med" len="med"/>
+                    </a:lnT>
+                    <a:lnB w="12700" cap="flat" cmpd="sng" algn="ctr">
+                      <a:solidFill>
+                        <a:schemeClr val="tx1"/>
+                      </a:solidFill>
+                      <a:prstDash val="solid"/>
+                      <a:round/>
+                      <a:headEnd type="none" w="med" len="med"/>
+                      <a:tailEnd type="none" w="med" len="med"/>
+                    </a:lnB>
+                  </a:tcPr>
+                </a:tc>
                 <a:extLst>
                   <a:ext uri="{0D108BD9-81ED-4DB2-BD59-A6C34878D82A}">
                     <a16:rowId xmlns:a16="http://schemas.microsoft.com/office/drawing/2014/main" val="199599739"/>
@@ -3471,6 +3679,100 @@
                 </a:extLst>
               </a:tr>
               <a:tr h="1192378">
+                <a:tc>
+                  <a:txBody>
+                    <a:bodyPr/>
+                    <a:lstStyle/>
+                    <a:p>
+                      <a:endParaRPr lang="en-US" dirty="0"/>
+                    </a:p>
+                  </a:txBody>
+                  <a:tcPr>
+                    <a:lnL w="12700" cap="flat" cmpd="sng" algn="ctr">
+                      <a:solidFill>
+                        <a:schemeClr val="tx1"/>
+                      </a:solidFill>
+                      <a:prstDash val="solid"/>
+                      <a:round/>
+                      <a:headEnd type="none" w="med" len="med"/>
+                      <a:tailEnd type="none" w="med" len="med"/>
+                    </a:lnL>
+                    <a:lnR w="12700" cap="flat" cmpd="sng" algn="ctr">
+                      <a:solidFill>
+                        <a:schemeClr val="tx1"/>
+                      </a:solidFill>
+                      <a:prstDash val="solid"/>
+                      <a:round/>
+                      <a:headEnd type="none" w="med" len="med"/>
+                      <a:tailEnd type="none" w="med" len="med"/>
+                    </a:lnR>
+                    <a:lnT w="12700" cap="flat" cmpd="sng" algn="ctr">
+                      <a:solidFill>
+                        <a:schemeClr val="tx1"/>
+                      </a:solidFill>
+                      <a:prstDash val="solid"/>
+                      <a:round/>
+                      <a:headEnd type="none" w="med" len="med"/>
+                      <a:tailEnd type="none" w="med" len="med"/>
+                    </a:lnT>
+                    <a:lnB w="12700" cap="flat" cmpd="sng" algn="ctr">
+                      <a:solidFill>
+                        <a:schemeClr val="tx1"/>
+                      </a:solidFill>
+                      <a:prstDash val="solid"/>
+                      <a:round/>
+                      <a:headEnd type="none" w="med" len="med"/>
+                      <a:tailEnd type="none" w="med" len="med"/>
+                    </a:lnB>
+                  </a:tcPr>
+                </a:tc>
+                <a:tc>
+                  <a:txBody>
+                    <a:bodyPr/>
+                    <a:lstStyle/>
+                    <a:p>
+                      <a:endParaRPr lang="en-US" dirty="0"/>
+                    </a:p>
+                  </a:txBody>
+                  <a:tcPr>
+                    <a:lnL w="12700" cap="flat" cmpd="sng" algn="ctr">
+                      <a:solidFill>
+                        <a:schemeClr val="tx1"/>
+                      </a:solidFill>
+                      <a:prstDash val="solid"/>
+                      <a:round/>
+                      <a:headEnd type="none" w="med" len="med"/>
+                      <a:tailEnd type="none" w="med" len="med"/>
+                    </a:lnL>
+                    <a:lnR w="12700" cap="flat" cmpd="sng" algn="ctr">
+                      <a:solidFill>
+                        <a:schemeClr val="tx1"/>
+                      </a:solidFill>
+                      <a:prstDash val="solid"/>
+                      <a:round/>
+                      <a:headEnd type="none" w="med" len="med"/>
+                      <a:tailEnd type="none" w="med" len="med"/>
+                    </a:lnR>
+                    <a:lnT w="12700" cap="flat" cmpd="sng" algn="ctr">
+                      <a:solidFill>
+                        <a:schemeClr val="tx1"/>
+                      </a:solidFill>
+                      <a:prstDash val="solid"/>
+                      <a:round/>
+                      <a:headEnd type="none" w="med" len="med"/>
+                      <a:tailEnd type="none" w="med" len="med"/>
+                    </a:lnT>
+                    <a:lnB w="12700" cap="flat" cmpd="sng" algn="ctr">
+                      <a:solidFill>
+                        <a:schemeClr val="tx1"/>
+                      </a:solidFill>
+                      <a:prstDash val="solid"/>
+                      <a:round/>
+                      <a:headEnd type="none" w="med" len="med"/>
+                      <a:tailEnd type="none" w="med" len="med"/>
+                    </a:lnB>
+                  </a:tcPr>
+                </a:tc>
                 <a:tc>
                   <a:txBody>
                     <a:bodyPr/>
@@ -3572,6 +3874,100 @@
                     </a:lnB>
                   </a:tcPr>
                 </a:tc>
+                <a:tc>
+                  <a:txBody>
+                    <a:bodyPr/>
+                    <a:lstStyle/>
+                    <a:p>
+                      <a:endParaRPr lang="en-US" dirty="0"/>
+                    </a:p>
+                  </a:txBody>
+                  <a:tcPr>
+                    <a:lnL w="12700" cap="flat" cmpd="sng" algn="ctr">
+                      <a:solidFill>
+                        <a:schemeClr val="tx1"/>
+                      </a:solidFill>
+                      <a:prstDash val="solid"/>
+                      <a:round/>
+                      <a:headEnd type="none" w="med" len="med"/>
+                      <a:tailEnd type="none" w="med" len="med"/>
+                    </a:lnL>
+                    <a:lnR w="12700" cap="flat" cmpd="sng" algn="ctr">
+                      <a:solidFill>
+                        <a:schemeClr val="tx1"/>
+                      </a:solidFill>
+                      <a:prstDash val="solid"/>
+                      <a:round/>
+                      <a:headEnd type="none" w="med" len="med"/>
+                      <a:tailEnd type="none" w="med" len="med"/>
+                    </a:lnR>
+                    <a:lnT w="12700" cap="flat" cmpd="sng" algn="ctr">
+                      <a:solidFill>
+                        <a:schemeClr val="tx1"/>
+                      </a:solidFill>
+                      <a:prstDash val="solid"/>
+                      <a:round/>
+                      <a:headEnd type="none" w="med" len="med"/>
+                      <a:tailEnd type="none" w="med" len="med"/>
+                    </a:lnT>
+                    <a:lnB w="12700" cap="flat" cmpd="sng" algn="ctr">
+                      <a:solidFill>
+                        <a:schemeClr val="tx1"/>
+                      </a:solidFill>
+                      <a:prstDash val="solid"/>
+                      <a:round/>
+                      <a:headEnd type="none" w="med" len="med"/>
+                      <a:tailEnd type="none" w="med" len="med"/>
+                    </a:lnB>
+                  </a:tcPr>
+                </a:tc>
+                <a:tc>
+                  <a:txBody>
+                    <a:bodyPr/>
+                    <a:lstStyle/>
+                    <a:p>
+                      <a:endParaRPr lang="en-US" dirty="0"/>
+                    </a:p>
+                  </a:txBody>
+                  <a:tcPr>
+                    <a:lnL w="12700" cap="flat" cmpd="sng" algn="ctr">
+                      <a:solidFill>
+                        <a:schemeClr val="tx1"/>
+                      </a:solidFill>
+                      <a:prstDash val="solid"/>
+                      <a:round/>
+                      <a:headEnd type="none" w="med" len="med"/>
+                      <a:tailEnd type="none" w="med" len="med"/>
+                    </a:lnL>
+                    <a:lnR w="12700" cap="flat" cmpd="sng" algn="ctr">
+                      <a:solidFill>
+                        <a:schemeClr val="tx1"/>
+                      </a:solidFill>
+                      <a:prstDash val="solid"/>
+                      <a:round/>
+                      <a:headEnd type="none" w="med" len="med"/>
+                      <a:tailEnd type="none" w="med" len="med"/>
+                    </a:lnR>
+                    <a:lnT w="12700" cap="flat" cmpd="sng" algn="ctr">
+                      <a:solidFill>
+                        <a:schemeClr val="tx1"/>
+                      </a:solidFill>
+                      <a:prstDash val="solid"/>
+                      <a:round/>
+                      <a:headEnd type="none" w="med" len="med"/>
+                      <a:tailEnd type="none" w="med" len="med"/>
+                    </a:lnT>
+                    <a:lnB w="12700" cap="flat" cmpd="sng" algn="ctr">
+                      <a:solidFill>
+                        <a:schemeClr val="tx1"/>
+                      </a:solidFill>
+                      <a:prstDash val="solid"/>
+                      <a:round/>
+                      <a:headEnd type="none" w="med" len="med"/>
+                      <a:tailEnd type="none" w="med" len="med"/>
+                    </a:lnB>
+                  </a:tcPr>
+                </a:tc>
                 <a:extLst>
                   <a:ext uri="{0D108BD9-81ED-4DB2-BD59-A6C34878D82A}">
                     <a16:rowId xmlns:a16="http://schemas.microsoft.com/office/drawing/2014/main" val="2437822257"/>
@@ -3626,6 +4022,100 @@
                     </a:lnB>
                   </a:tcPr>
                 </a:tc>
+                <a:tc>
+                  <a:txBody>
+                    <a:bodyPr/>
+                    <a:lstStyle/>
+                    <a:p>
+                      <a:endParaRPr lang="en-US" dirty="0"/>
+                    </a:p>
+                  </a:txBody>
+                  <a:tcPr>
+                    <a:lnL w="12700" cap="flat" cmpd="sng" algn="ctr">
+                      <a:solidFill>
+                        <a:schemeClr val="tx1"/>
+                      </a:solidFill>
+                      <a:prstDash val="solid"/>
+                      <a:round/>
+                      <a:headEnd type="none" w="med" len="med"/>
+                      <a:tailEnd type="none" w="med" len="med"/>
+                    </a:lnL>
+                    <a:lnR w="12700" cap="flat" cmpd="sng" algn="ctr">
+                      <a:solidFill>
+                        <a:schemeClr val="tx1"/>
+                      </a:solidFill>
+                      <a:prstDash val="solid"/>
+                      <a:round/>
+                      <a:headEnd type="none" w="med" len="med"/>
+                      <a:tailEnd type="none" w="med" len="med"/>
+                    </a:lnR>
+                    <a:lnT w="12700" cap="flat" cmpd="sng" algn="ctr">
+                      <a:solidFill>
+                        <a:schemeClr val="tx1"/>
+                      </a:solidFill>
+                      <a:prstDash val="solid"/>
+                      <a:round/>
+                      <a:headEnd type="none" w="med" len="med"/>
+                      <a:tailEnd type="none" w="med" len="med"/>
+                    </a:lnT>
+                    <a:lnB w="12700" cap="flat" cmpd="sng" algn="ctr">
+                      <a:solidFill>
+                        <a:schemeClr val="tx1"/>
+                      </a:solidFill>
+                      <a:prstDash val="solid"/>
+                      <a:round/>
+                      <a:headEnd type="none" w="med" len="med"/>
+                      <a:tailEnd type="none" w="med" len="med"/>
+                    </a:lnB>
+                  </a:tcPr>
+                </a:tc>
+                <a:tc>
+                  <a:txBody>
+                    <a:bodyPr/>
+                    <a:lstStyle/>
+                    <a:p>
+                      <a:endParaRPr lang="en-US" dirty="0"/>
+                    </a:p>
+                  </a:txBody>
+                  <a:tcPr>
+                    <a:lnL w="12700" cap="flat" cmpd="sng" algn="ctr">
+                      <a:solidFill>
+                        <a:schemeClr val="tx1"/>
+                      </a:solidFill>
+                      <a:prstDash val="solid"/>
+                      <a:round/>
+                      <a:headEnd type="none" w="med" len="med"/>
+                      <a:tailEnd type="none" w="med" len="med"/>
+                    </a:lnL>
+                    <a:lnR w="12700" cap="flat" cmpd="sng" algn="ctr">
+                      <a:solidFill>
+                        <a:schemeClr val="tx1"/>
+                      </a:solidFill>
+                      <a:prstDash val="solid"/>
+                      <a:round/>
+                      <a:headEnd type="none" w="med" len="med"/>
+                      <a:tailEnd type="none" w="med" len="med"/>
+                    </a:lnR>
+                    <a:lnT w="12700" cap="flat" cmpd="sng" algn="ctr">
+                      <a:solidFill>
+                        <a:schemeClr val="tx1"/>
+                      </a:solidFill>
+                      <a:prstDash val="solid"/>
+                      <a:round/>
+                      <a:headEnd type="none" w="med" len="med"/>
+                      <a:tailEnd type="none" w="med" len="med"/>
+                    </a:lnT>
+                    <a:lnB w="12700" cap="flat" cmpd="sng" algn="ctr">
+                      <a:solidFill>
+                        <a:schemeClr val="tx1"/>
+                      </a:solidFill>
+                      <a:prstDash val="solid"/>
+                      <a:round/>
+                      <a:headEnd type="none" w="med" len="med"/>
+                      <a:tailEnd type="none" w="med" len="med"/>
+                    </a:lnB>
+                  </a:tcPr>
+                </a:tc>
                 <a:extLst>
                   <a:ext uri="{0D108BD9-81ED-4DB2-BD59-A6C34878D82A}">
                     <a16:rowId xmlns:a16="http://schemas.microsoft.com/office/drawing/2014/main" val="2616521330"/>
@@ -3723,7 +4213,7 @@
         <p:spPr>
           <a:xfrm>
             <a:off x="2721864" y="2816682"/>
-            <a:ext cx="1298448" cy="877163"/>
+            <a:ext cx="1298448" cy="369332"/>
           </a:xfrm>
           <a:prstGeom prst="rect">
             <a:avLst/>
@@ -3739,12 +4229,9 @@
             <a:pPr algn="ctr"/>
             <a:r>
               <a:rPr lang="en-US" dirty="0"/>
-              <a:t>Reactor: </a:t>
-            </a:r>
-            <a:r>
-              <a:rPr lang="en-US" sz="1100" dirty="0"/>
-              <a:t>Large, Titanium, Volatile (Catastrophic) </a:t>
-            </a:r>
+              <a:t>Reactor</a:t>
+            </a:r>
+            <a:endParaRPr lang="en-US" sz="1100" dirty="0"/>
           </a:p>
         </p:txBody>
       </p:sp>
@@ -3763,7 +4250,7 @@
         <p:spPr>
           <a:xfrm>
             <a:off x="5096256" y="3998898"/>
-            <a:ext cx="1298448" cy="984885"/>
+            <a:ext cx="1298448" cy="646331"/>
           </a:xfrm>
           <a:prstGeom prst="rect">
             <a:avLst/>
@@ -3779,12 +4266,9 @@
             <a:pPr algn="ctr"/>
             <a:r>
               <a:rPr lang="en-US" dirty="0"/>
-              <a:t>Computer Console: </a:t>
-            </a:r>
-            <a:r>
-              <a:rPr lang="en-US" sz="1100" dirty="0"/>
-              <a:t>Large, Computer, Aluminum</a:t>
-            </a:r>
+              <a:t>Computer Console</a:t>
+            </a:r>
+            <a:endParaRPr lang="en-US" sz="1100" dirty="0"/>
           </a:p>
         </p:txBody>
       </p:sp>
@@ -3803,7 +4287,7 @@
         <p:spPr>
           <a:xfrm>
             <a:off x="512064" y="3998898"/>
-            <a:ext cx="1298448" cy="984885"/>
+            <a:ext cx="1298448" cy="646331"/>
           </a:xfrm>
           <a:prstGeom prst="rect">
             <a:avLst/>
@@ -3819,12 +4303,9 @@
             <a:pPr algn="ctr"/>
             <a:r>
               <a:rPr lang="en-US" dirty="0"/>
-              <a:t>Computer Console: </a:t>
-            </a:r>
-            <a:r>
-              <a:rPr lang="en-US" sz="1100" dirty="0"/>
-              <a:t>Large, Computer, Aluminum</a:t>
-            </a:r>
+              <a:t>Computer Console</a:t>
+            </a:r>
+            <a:endParaRPr lang="en-US" sz="1100" dirty="0"/>
           </a:p>
         </p:txBody>
       </p:sp>
@@ -3843,7 +4324,7 @@
         <p:spPr>
           <a:xfrm>
             <a:off x="512064" y="1526970"/>
-            <a:ext cx="1298448" cy="984885"/>
+            <a:ext cx="1298448" cy="646331"/>
           </a:xfrm>
           <a:prstGeom prst="rect">
             <a:avLst/>
@@ -3859,12 +4340,9 @@
             <a:pPr algn="ctr"/>
             <a:r>
               <a:rPr lang="en-US" dirty="0"/>
-              <a:t>Computer Console: </a:t>
-            </a:r>
-            <a:r>
-              <a:rPr lang="en-US" sz="1100" dirty="0"/>
-              <a:t>Large, Computer, Aluminum</a:t>
-            </a:r>
+              <a:t>Computer Console</a:t>
+            </a:r>
+            <a:endParaRPr lang="en-US" sz="1100" dirty="0"/>
           </a:p>
         </p:txBody>
       </p:sp>
@@ -3883,7 +4361,7 @@
         <p:spPr>
           <a:xfrm>
             <a:off x="4974336" y="1526970"/>
-            <a:ext cx="1298448" cy="984885"/>
+            <a:ext cx="1298448" cy="646331"/>
           </a:xfrm>
           <a:prstGeom prst="rect">
             <a:avLst/>
@@ -3899,21 +4377,18 @@
             <a:pPr algn="ctr"/>
             <a:r>
               <a:rPr lang="en-US" dirty="0"/>
-              <a:t>Computer Console: </a:t>
-            </a:r>
-            <a:r>
-              <a:rPr lang="en-US" sz="1100" dirty="0"/>
-              <a:t>Large, Computer, Aluminum</a:t>
-            </a:r>
-          </a:p>
-        </p:txBody>
-      </p:sp>
-      <p:sp>
-        <p:nvSpPr>
-          <p:cNvPr id="16" name="TextBox 15">
-            <a:extLst>
-              <a:ext uri="{FF2B5EF4-FFF2-40B4-BE49-F238E27FC236}">
-                <a16:creationId xmlns:a16="http://schemas.microsoft.com/office/drawing/2014/main" id="{F430000D-CDA0-010C-B9A3-51909F96E6E2}"/>
+              <a:t>Computer Console</a:t>
+            </a:r>
+            <a:endParaRPr lang="en-US" sz="1100" dirty="0"/>
+          </a:p>
+        </p:txBody>
+      </p:sp>
+      <p:sp>
+        <p:nvSpPr>
+          <p:cNvPr id="20" name="TextBox 19">
+            <a:extLst>
+              <a:ext uri="{FF2B5EF4-FFF2-40B4-BE49-F238E27FC236}">
+                <a16:creationId xmlns:a16="http://schemas.microsoft.com/office/drawing/2014/main" id="{2C1FEDC6-96A9-21A8-F87E-FD8385A5C317}"/>
               </a:ext>
             </a:extLst>
           </p:cNvPr>
@@ -3922,8 +4397,8 @@
         </p:nvSpPr>
         <p:spPr>
           <a:xfrm>
-            <a:off x="512064" y="5425329"/>
-            <a:ext cx="1298448" cy="369332"/>
+            <a:off x="7214616" y="393192"/>
+            <a:ext cx="4581144" cy="5355312"/>
           </a:xfrm>
           <a:prstGeom prst="rect">
             <a:avLst/>
@@ -3936,154 +4411,6 @@
           </a:bodyPr>
           <a:lstStyle/>
           <a:p>
-            <a:pPr algn="ctr"/>
-            <a:r>
-              <a:rPr lang="en-US" dirty="0"/>
-              <a:t>Catwalk</a:t>
-            </a:r>
-            <a:endParaRPr lang="en-US" sz="1100" dirty="0"/>
-          </a:p>
-        </p:txBody>
-      </p:sp>
-      <p:sp>
-        <p:nvSpPr>
-          <p:cNvPr id="17" name="TextBox 16">
-            <a:extLst>
-              <a:ext uri="{FF2B5EF4-FFF2-40B4-BE49-F238E27FC236}">
-                <a16:creationId xmlns:a16="http://schemas.microsoft.com/office/drawing/2014/main" id="{EED0AC1C-73EA-CA20-2A07-9823421FFE1C}"/>
-              </a:ext>
-            </a:extLst>
-          </p:cNvPr>
-          <p:cNvSpPr txBox="1"/>
-          <p:nvPr/>
-        </p:nvSpPr>
-        <p:spPr>
-          <a:xfrm>
-            <a:off x="5184648" y="5425329"/>
-            <a:ext cx="1298448" cy="369332"/>
-          </a:xfrm>
-          <a:prstGeom prst="rect">
-            <a:avLst/>
-          </a:prstGeom>
-          <a:noFill/>
-        </p:spPr>
-        <p:txBody>
-          <a:bodyPr wrap="square" rtlCol="0">
-            <a:spAutoFit/>
-          </a:bodyPr>
-          <a:lstStyle/>
-          <a:p>
-            <a:pPr algn="ctr"/>
-            <a:r>
-              <a:rPr lang="en-US" dirty="0"/>
-              <a:t>Catwalk</a:t>
-            </a:r>
-            <a:endParaRPr lang="en-US" sz="1100" dirty="0"/>
-          </a:p>
-        </p:txBody>
-      </p:sp>
-      <p:sp>
-        <p:nvSpPr>
-          <p:cNvPr id="18" name="TextBox 17">
-            <a:extLst>
-              <a:ext uri="{FF2B5EF4-FFF2-40B4-BE49-F238E27FC236}">
-                <a16:creationId xmlns:a16="http://schemas.microsoft.com/office/drawing/2014/main" id="{81FC5424-BFD4-08A4-3631-B0FD8008DB06}"/>
-              </a:ext>
-            </a:extLst>
-          </p:cNvPr>
-          <p:cNvSpPr txBox="1"/>
-          <p:nvPr/>
-        </p:nvSpPr>
-        <p:spPr>
-          <a:xfrm>
-            <a:off x="512064" y="715979"/>
-            <a:ext cx="1298448" cy="369332"/>
-          </a:xfrm>
-          <a:prstGeom prst="rect">
-            <a:avLst/>
-          </a:prstGeom>
-          <a:noFill/>
-        </p:spPr>
-        <p:txBody>
-          <a:bodyPr wrap="square" rtlCol="0">
-            <a:spAutoFit/>
-          </a:bodyPr>
-          <a:lstStyle/>
-          <a:p>
-            <a:pPr algn="ctr"/>
-            <a:r>
-              <a:rPr lang="en-US" dirty="0"/>
-              <a:t>Catwalk</a:t>
-            </a:r>
-            <a:endParaRPr lang="en-US" sz="1100" dirty="0"/>
-          </a:p>
-        </p:txBody>
-      </p:sp>
-      <p:sp>
-        <p:nvSpPr>
-          <p:cNvPr id="19" name="TextBox 18">
-            <a:extLst>
-              <a:ext uri="{FF2B5EF4-FFF2-40B4-BE49-F238E27FC236}">
-                <a16:creationId xmlns:a16="http://schemas.microsoft.com/office/drawing/2014/main" id="{6784DB42-E6E1-1944-DD9E-20D90A54253F}"/>
-              </a:ext>
-            </a:extLst>
-          </p:cNvPr>
-          <p:cNvSpPr txBox="1"/>
-          <p:nvPr/>
-        </p:nvSpPr>
-        <p:spPr>
-          <a:xfrm>
-            <a:off x="5096256" y="614434"/>
-            <a:ext cx="1298448" cy="369332"/>
-          </a:xfrm>
-          <a:prstGeom prst="rect">
-            <a:avLst/>
-          </a:prstGeom>
-          <a:noFill/>
-        </p:spPr>
-        <p:txBody>
-          <a:bodyPr wrap="square" rtlCol="0">
-            <a:spAutoFit/>
-          </a:bodyPr>
-          <a:lstStyle/>
-          <a:p>
-            <a:pPr algn="ctr"/>
-            <a:r>
-              <a:rPr lang="en-US" dirty="0"/>
-              <a:t>Catwalk</a:t>
-            </a:r>
-            <a:endParaRPr lang="en-US" sz="1100" dirty="0"/>
-          </a:p>
-        </p:txBody>
-      </p:sp>
-      <p:sp>
-        <p:nvSpPr>
-          <p:cNvPr id="20" name="TextBox 19">
-            <a:extLst>
-              <a:ext uri="{FF2B5EF4-FFF2-40B4-BE49-F238E27FC236}">
-                <a16:creationId xmlns:a16="http://schemas.microsoft.com/office/drawing/2014/main" id="{2C1FEDC6-96A9-21A8-F87E-FD8385A5C317}"/>
-              </a:ext>
-            </a:extLst>
-          </p:cNvPr>
-          <p:cNvSpPr txBox="1"/>
-          <p:nvPr/>
-        </p:nvSpPr>
-        <p:spPr>
-          <a:xfrm>
-            <a:off x="7214616" y="393192"/>
-            <a:ext cx="4581144" cy="5909310"/>
-          </a:xfrm>
-          <a:prstGeom prst="rect">
-            <a:avLst/>
-          </a:prstGeom>
-          <a:noFill/>
-        </p:spPr>
-        <p:txBody>
-          <a:bodyPr wrap="square" rtlCol="0">
-            <a:spAutoFit/>
-          </a:bodyPr>
-          <a:lstStyle/>
-          <a:p>
             <a:r>
               <a:rPr lang="en-US" dirty="0"/>
               <a:t>Door: Entry to the space – the players always enter from the bottom, all other space is oriented likewise. Doors are placed first when building a room. Can only use a door as cover if its closed. </a:t>
@@ -4114,7 +4441,15 @@
           <a:p>
             <a:r>
               <a:rPr lang="en-US" dirty="0"/>
-              <a:t>Computer Console: Large (up to 4 characters can use it for cover on a side), Computer (grants access to ship systems), Aluminum (Certain TGH rating and damage modifiers)</a:t>
+              <a:t>Computer Console</a:t>
+            </a:r>
+            <a:r>
+              <a:rPr lang="en-US"/>
+              <a:t>:  Computer </a:t>
+            </a:r>
+            <a:r>
+              <a:rPr lang="en-US" dirty="0"/>
+              <a:t>(grants access to ship systems), Aluminum (Certain TGH rating and damage modifiers)</a:t>
             </a:r>
           </a:p>
           <a:p>
@@ -4146,7 +4481,7 @@
         <p:cNvPr id="1" name="">
           <a:extLst>
             <a:ext uri="{FF2B5EF4-FFF2-40B4-BE49-F238E27FC236}">
-              <a16:creationId xmlns:a16="http://schemas.microsoft.com/office/drawing/2014/main" id="{80F3BD18-4596-25DE-BA97-AE5D5B090BA1}"/>
+              <a16:creationId xmlns:a16="http://schemas.microsoft.com/office/drawing/2014/main" id="{DE656357-2955-2B4E-89A1-95BDAD34021F}"/>
             </a:ext>
           </a:extLst>
         </p:cNvPr>
@@ -4166,7 +4501,7 @@
           <p:cNvPr id="5" name="Table 4">
             <a:extLst>
               <a:ext uri="{FF2B5EF4-FFF2-40B4-BE49-F238E27FC236}">
-                <a16:creationId xmlns:a16="http://schemas.microsoft.com/office/drawing/2014/main" id="{9EBCFD90-4C66-3038-EB4F-463DAACEE5E5}"/>
+                <a16:creationId xmlns:a16="http://schemas.microsoft.com/office/drawing/2014/main" id="{999CE8CB-43A4-C505-F993-704FF5B39F8D}"/>
               </a:ext>
             </a:extLst>
           </p:cNvPr>
@@ -4176,7 +4511,7 @@
           <p:nvPr>
             <p:extLst>
               <p:ext uri="{D42A27DB-BD31-4B8C-83A1-F6EECF244321}">
-                <p14:modId xmlns:p14="http://schemas.microsoft.com/office/powerpoint/2010/main" val="1710018941"/>
+                <p14:modId xmlns:p14="http://schemas.microsoft.com/office/powerpoint/2010/main" val="3888912092"/>
               </p:ext>
             </p:extLst>
           </p:nvPr>
@@ -4192,10 +4527,24 @@
                 <a:tableStyleId>{2D5ABB26-0587-4C30-8999-92F81FD0307C}</a:tableStyleId>
               </a:tblPr>
               <a:tblGrid>
-                <a:gridCol w="6720840">
+                <a:gridCol w="2240280">
                   <a:extLst>
                     <a:ext uri="{9D8B030D-6E8A-4147-A177-3AD203B41FA5}">
                       <a16:colId xmlns:a16="http://schemas.microsoft.com/office/drawing/2014/main" val="2115971656"/>
+                    </a:ext>
+                  </a:extLst>
+                </a:gridCol>
+                <a:gridCol w="2240280">
+                  <a:extLst>
+                    <a:ext uri="{9D8B030D-6E8A-4147-A177-3AD203B41FA5}">
+                      <a16:colId xmlns:a16="http://schemas.microsoft.com/office/drawing/2014/main" val="2342515225"/>
+                    </a:ext>
+                  </a:extLst>
+                </a:gridCol>
+                <a:gridCol w="2240280">
+                  <a:extLst>
+                    <a:ext uri="{9D8B030D-6E8A-4147-A177-3AD203B41FA5}">
+                      <a16:colId xmlns:a16="http://schemas.microsoft.com/office/drawing/2014/main" val="1334408846"/>
                     </a:ext>
                   </a:extLst>
                 </a:gridCol>
@@ -4215,6 +4564,100 @@
                         <a:schemeClr val="tx1"/>
                       </a:solidFill>
                       <a:prstDash val="solid"/>
+                      <a:round/>
+                      <a:headEnd type="none" w="med" len="med"/>
+                      <a:tailEnd type="none" w="med" len="med"/>
+                    </a:lnL>
+                    <a:lnR w="12700" cap="flat" cmpd="sng" algn="ctr">
+                      <a:solidFill>
+                        <a:schemeClr val="tx1"/>
+                      </a:solidFill>
+                      <a:prstDash val="sysDash"/>
+                      <a:round/>
+                      <a:headEnd type="none" w="med" len="med"/>
+                      <a:tailEnd type="none" w="med" len="med"/>
+                    </a:lnR>
+                    <a:lnT w="12700" cap="flat" cmpd="sng" algn="ctr">
+                      <a:solidFill>
+                        <a:schemeClr val="tx1"/>
+                      </a:solidFill>
+                      <a:prstDash val="solid"/>
+                      <a:round/>
+                      <a:headEnd type="none" w="med" len="med"/>
+                      <a:tailEnd type="none" w="med" len="med"/>
+                    </a:lnT>
+                    <a:lnB w="12700" cap="flat" cmpd="sng" algn="ctr">
+                      <a:solidFill>
+                        <a:schemeClr val="tx1"/>
+                      </a:solidFill>
+                      <a:prstDash val="solid"/>
+                      <a:round/>
+                      <a:headEnd type="none" w="med" len="med"/>
+                      <a:tailEnd type="none" w="med" len="med"/>
+                    </a:lnB>
+                  </a:tcPr>
+                </a:tc>
+                <a:tc>
+                  <a:txBody>
+                    <a:bodyPr/>
+                    <a:lstStyle/>
+                    <a:p>
+                      <a:endParaRPr lang="en-US" dirty="0"/>
+                    </a:p>
+                  </a:txBody>
+                  <a:tcPr>
+                    <a:lnL w="12700" cap="flat" cmpd="sng" algn="ctr">
+                      <a:solidFill>
+                        <a:schemeClr val="tx1"/>
+                      </a:solidFill>
+                      <a:prstDash val="sysDash"/>
+                      <a:round/>
+                      <a:headEnd type="none" w="med" len="med"/>
+                      <a:tailEnd type="none" w="med" len="med"/>
+                    </a:lnL>
+                    <a:lnR w="12700" cap="flat" cmpd="sng" algn="ctr">
+                      <a:solidFill>
+                        <a:schemeClr val="tx1"/>
+                      </a:solidFill>
+                      <a:prstDash val="sysDash"/>
+                      <a:round/>
+                      <a:headEnd type="none" w="med" len="med"/>
+                      <a:tailEnd type="none" w="med" len="med"/>
+                    </a:lnR>
+                    <a:lnT w="12700" cap="flat" cmpd="sng" algn="ctr">
+                      <a:solidFill>
+                        <a:schemeClr val="tx1"/>
+                      </a:solidFill>
+                      <a:prstDash val="solid"/>
+                      <a:round/>
+                      <a:headEnd type="none" w="med" len="med"/>
+                      <a:tailEnd type="none" w="med" len="med"/>
+                    </a:lnT>
+                    <a:lnB w="12700" cap="flat" cmpd="sng" algn="ctr">
+                      <a:solidFill>
+                        <a:schemeClr val="tx1"/>
+                      </a:solidFill>
+                      <a:prstDash val="solid"/>
+                      <a:round/>
+                      <a:headEnd type="none" w="med" len="med"/>
+                      <a:tailEnd type="none" w="med" len="med"/>
+                    </a:lnB>
+                  </a:tcPr>
+                </a:tc>
+                <a:tc>
+                  <a:txBody>
+                    <a:bodyPr/>
+                    <a:lstStyle/>
+                    <a:p>
+                      <a:endParaRPr lang="en-US" dirty="0"/>
+                    </a:p>
+                  </a:txBody>
+                  <a:tcPr>
+                    <a:lnL w="12700" cap="flat" cmpd="sng" algn="ctr">
+                      <a:solidFill>
+                        <a:schemeClr val="tx1"/>
+                      </a:solidFill>
+                      <a:prstDash val="sysDash"/>
                       <a:round/>
                       <a:headEnd type="none" w="med" len="med"/>
                       <a:tailEnd type="none" w="med" len="med"/>
@@ -4277,6 +4720,100 @@
                       <a:solidFill>
                         <a:schemeClr val="tx1"/>
                       </a:solidFill>
+                      <a:prstDash val="sysDash"/>
+                      <a:round/>
+                      <a:headEnd type="none" w="med" len="med"/>
+                      <a:tailEnd type="none" w="med" len="med"/>
+                    </a:lnR>
+                    <a:lnT w="12700" cap="flat" cmpd="sng" algn="ctr">
+                      <a:solidFill>
+                        <a:schemeClr val="tx1"/>
+                      </a:solidFill>
+                      <a:prstDash val="solid"/>
+                      <a:round/>
+                      <a:headEnd type="none" w="med" len="med"/>
+                      <a:tailEnd type="none" w="med" len="med"/>
+                    </a:lnT>
+                    <a:lnB w="12700" cap="flat" cmpd="sng" algn="ctr">
+                      <a:solidFill>
+                        <a:schemeClr val="tx1"/>
+                      </a:solidFill>
+                      <a:prstDash val="solid"/>
+                      <a:round/>
+                      <a:headEnd type="none" w="med" len="med"/>
+                      <a:tailEnd type="none" w="med" len="med"/>
+                    </a:lnB>
+                  </a:tcPr>
+                </a:tc>
+                <a:tc>
+                  <a:txBody>
+                    <a:bodyPr/>
+                    <a:lstStyle/>
+                    <a:p>
+                      <a:endParaRPr lang="en-US" dirty="0"/>
+                    </a:p>
+                  </a:txBody>
+                  <a:tcPr>
+                    <a:lnL w="12700" cap="flat" cmpd="sng" algn="ctr">
+                      <a:solidFill>
+                        <a:schemeClr val="tx1"/>
+                      </a:solidFill>
+                      <a:prstDash val="sysDash"/>
+                      <a:round/>
+                      <a:headEnd type="none" w="med" len="med"/>
+                      <a:tailEnd type="none" w="med" len="med"/>
+                    </a:lnL>
+                    <a:lnR w="12700" cap="flat" cmpd="sng" algn="ctr">
+                      <a:solidFill>
+                        <a:schemeClr val="tx1"/>
+                      </a:solidFill>
+                      <a:prstDash val="sysDash"/>
+                      <a:round/>
+                      <a:headEnd type="none" w="med" len="med"/>
+                      <a:tailEnd type="none" w="med" len="med"/>
+                    </a:lnR>
+                    <a:lnT w="12700" cap="flat" cmpd="sng" algn="ctr">
+                      <a:solidFill>
+                        <a:schemeClr val="tx1"/>
+                      </a:solidFill>
+                      <a:prstDash val="solid"/>
+                      <a:round/>
+                      <a:headEnd type="none" w="med" len="med"/>
+                      <a:tailEnd type="none" w="med" len="med"/>
+                    </a:lnT>
+                    <a:lnB w="12700" cap="flat" cmpd="sng" algn="ctr">
+                      <a:solidFill>
+                        <a:schemeClr val="tx1"/>
+                      </a:solidFill>
+                      <a:prstDash val="solid"/>
+                      <a:round/>
+                      <a:headEnd type="none" w="med" len="med"/>
+                      <a:tailEnd type="none" w="med" len="med"/>
+                    </a:lnB>
+                  </a:tcPr>
+                </a:tc>
+                <a:tc>
+                  <a:txBody>
+                    <a:bodyPr/>
+                    <a:lstStyle/>
+                    <a:p>
+                      <a:endParaRPr lang="en-US" dirty="0"/>
+                    </a:p>
+                  </a:txBody>
+                  <a:tcPr>
+                    <a:lnL w="12700" cap="flat" cmpd="sng" algn="ctr">
+                      <a:solidFill>
+                        <a:schemeClr val="tx1"/>
+                      </a:solidFill>
+                      <a:prstDash val="sysDash"/>
+                      <a:round/>
+                      <a:headEnd type="none" w="med" len="med"/>
+                      <a:tailEnd type="none" w="med" len="med"/>
+                    </a:lnL>
+                    <a:lnR w="12700" cap="flat" cmpd="sng" algn="ctr">
+                      <a:solidFill>
+                        <a:schemeClr val="tx1"/>
+                      </a:solidFill>
                       <a:prstDash val="solid"/>
                       <a:round/>
                       <a:headEnd type="none" w="med" len="med"/>
@@ -4331,6 +4868,100 @@
                       <a:solidFill>
                         <a:schemeClr val="tx1"/>
                       </a:solidFill>
+                      <a:prstDash val="sysDash"/>
+                      <a:round/>
+                      <a:headEnd type="none" w="med" len="med"/>
+                      <a:tailEnd type="none" w="med" len="med"/>
+                    </a:lnR>
+                    <a:lnT w="12700" cap="flat" cmpd="sng" algn="ctr">
+                      <a:solidFill>
+                        <a:schemeClr val="tx1"/>
+                      </a:solidFill>
+                      <a:prstDash val="solid"/>
+                      <a:round/>
+                      <a:headEnd type="none" w="med" len="med"/>
+                      <a:tailEnd type="none" w="med" len="med"/>
+                    </a:lnT>
+                    <a:lnB w="12700" cap="flat" cmpd="sng" algn="ctr">
+                      <a:solidFill>
+                        <a:schemeClr val="tx1"/>
+                      </a:solidFill>
+                      <a:prstDash val="solid"/>
+                      <a:round/>
+                      <a:headEnd type="none" w="med" len="med"/>
+                      <a:tailEnd type="none" w="med" len="med"/>
+                    </a:lnB>
+                  </a:tcPr>
+                </a:tc>
+                <a:tc>
+                  <a:txBody>
+                    <a:bodyPr/>
+                    <a:lstStyle/>
+                    <a:p>
+                      <a:endParaRPr lang="en-US" dirty="0"/>
+                    </a:p>
+                  </a:txBody>
+                  <a:tcPr>
+                    <a:lnL w="12700" cap="flat" cmpd="sng" algn="ctr">
+                      <a:solidFill>
+                        <a:schemeClr val="tx1"/>
+                      </a:solidFill>
+                      <a:prstDash val="sysDash"/>
+                      <a:round/>
+                      <a:headEnd type="none" w="med" len="med"/>
+                      <a:tailEnd type="none" w="med" len="med"/>
+                    </a:lnL>
+                    <a:lnR w="12700" cap="flat" cmpd="sng" algn="ctr">
+                      <a:solidFill>
+                        <a:schemeClr val="tx1"/>
+                      </a:solidFill>
+                      <a:prstDash val="sysDash"/>
+                      <a:round/>
+                      <a:headEnd type="none" w="med" len="med"/>
+                      <a:tailEnd type="none" w="med" len="med"/>
+                    </a:lnR>
+                    <a:lnT w="12700" cap="flat" cmpd="sng" algn="ctr">
+                      <a:solidFill>
+                        <a:schemeClr val="tx1"/>
+                      </a:solidFill>
+                      <a:prstDash val="solid"/>
+                      <a:round/>
+                      <a:headEnd type="none" w="med" len="med"/>
+                      <a:tailEnd type="none" w="med" len="med"/>
+                    </a:lnT>
+                    <a:lnB w="12700" cap="flat" cmpd="sng" algn="ctr">
+                      <a:solidFill>
+                        <a:schemeClr val="tx1"/>
+                      </a:solidFill>
+                      <a:prstDash val="solid"/>
+                      <a:round/>
+                      <a:headEnd type="none" w="med" len="med"/>
+                      <a:tailEnd type="none" w="med" len="med"/>
+                    </a:lnB>
+                  </a:tcPr>
+                </a:tc>
+                <a:tc>
+                  <a:txBody>
+                    <a:bodyPr/>
+                    <a:lstStyle/>
+                    <a:p>
+                      <a:endParaRPr lang="en-US" dirty="0"/>
+                    </a:p>
+                  </a:txBody>
+                  <a:tcPr>
+                    <a:lnL w="12700" cap="flat" cmpd="sng" algn="ctr">
+                      <a:solidFill>
+                        <a:schemeClr val="tx1"/>
+                      </a:solidFill>
+                      <a:prstDash val="sysDash"/>
+                      <a:round/>
+                      <a:headEnd type="none" w="med" len="med"/>
+                      <a:tailEnd type="none" w="med" len="med"/>
+                    </a:lnL>
+                    <a:lnR w="12700" cap="flat" cmpd="sng" algn="ctr">
+                      <a:solidFill>
+                        <a:schemeClr val="tx1"/>
+                      </a:solidFill>
                       <a:prstDash val="solid"/>
                       <a:round/>
                       <a:headEnd type="none" w="med" len="med"/>
@@ -4371,7 +5002,7 @@
           <p:cNvPr id="6" name="TextBox 5">
             <a:extLst>
               <a:ext uri="{FF2B5EF4-FFF2-40B4-BE49-F238E27FC236}">
-                <a16:creationId xmlns:a16="http://schemas.microsoft.com/office/drawing/2014/main" id="{E27CB9D2-B20D-F17C-D4BA-7DA1DB507914}"/>
+                <a16:creationId xmlns:a16="http://schemas.microsoft.com/office/drawing/2014/main" id="{0440817D-C083-3623-C492-F0A30D4E67DF}"/>
               </a:ext>
             </a:extLst>
           </p:cNvPr>
@@ -4407,7 +5038,7 @@
           <p:cNvPr id="7" name="TextBox 6">
             <a:extLst>
               <a:ext uri="{FF2B5EF4-FFF2-40B4-BE49-F238E27FC236}">
-                <a16:creationId xmlns:a16="http://schemas.microsoft.com/office/drawing/2014/main" id="{BC1D4C4A-B525-E289-B090-7464BF9C8AB8}"/>
+                <a16:creationId xmlns:a16="http://schemas.microsoft.com/office/drawing/2014/main" id="{848C6F16-7594-8302-67CC-B454F2BAD739}"/>
               </a:ext>
             </a:extLst>
           </p:cNvPr>
@@ -4443,7 +5074,7 @@
           <p:cNvPr id="2" name="TextBox 1">
             <a:extLst>
               <a:ext uri="{FF2B5EF4-FFF2-40B4-BE49-F238E27FC236}">
-                <a16:creationId xmlns:a16="http://schemas.microsoft.com/office/drawing/2014/main" id="{B4DD859C-618D-F89F-5D64-600C32D9BBAC}"/>
+                <a16:creationId xmlns:a16="http://schemas.microsoft.com/office/drawing/2014/main" id="{29C59139-5327-59C3-0125-6710D92C9E63}"/>
               </a:ext>
             </a:extLst>
           </p:cNvPr>
@@ -4479,7 +5110,7 @@
           <p:cNvPr id="3" name="TextBox 2">
             <a:extLst>
               <a:ext uri="{FF2B5EF4-FFF2-40B4-BE49-F238E27FC236}">
-                <a16:creationId xmlns:a16="http://schemas.microsoft.com/office/drawing/2014/main" id="{708861DF-848F-AD10-FA43-43968258826B}"/>
+                <a16:creationId xmlns:a16="http://schemas.microsoft.com/office/drawing/2014/main" id="{E8ED9A26-BD66-E3BB-B003-1E2552133686}"/>
               </a:ext>
             </a:extLst>
           </p:cNvPr>
@@ -4515,7 +5146,7 @@
           <p:cNvPr id="4" name="TextBox 3">
             <a:extLst>
               <a:ext uri="{FF2B5EF4-FFF2-40B4-BE49-F238E27FC236}">
-                <a16:creationId xmlns:a16="http://schemas.microsoft.com/office/drawing/2014/main" id="{E07EC755-ABAF-FA4D-4912-B38302FA9154}"/>
+                <a16:creationId xmlns:a16="http://schemas.microsoft.com/office/drawing/2014/main" id="{C61E060A-1BE3-D77B-1B9D-CE1E86C92185}"/>
               </a:ext>
             </a:extLst>
           </p:cNvPr>
@@ -4556,7 +5187,7 @@
     </p:spTree>
     <p:extLst>
       <p:ext uri="{BB962C8B-B14F-4D97-AF65-F5344CB8AC3E}">
-        <p14:creationId xmlns:p14="http://schemas.microsoft.com/office/powerpoint/2010/main" val="1693436605"/>
+        <p14:creationId xmlns:p14="http://schemas.microsoft.com/office/powerpoint/2010/main" val="332015828"/>
       </p:ext>
     </p:extLst>
   </p:cSld>
@@ -4567,6 +5198,1978 @@
 </file>
 
 <file path=ppt/slides/slide3.xml><?xml version="1.0" encoding="utf-8"?>
+<p:sld xmlns:a="http://schemas.openxmlformats.org/drawingml/2006/main" xmlns:r="http://schemas.openxmlformats.org/officeDocument/2006/relationships" xmlns:p="http://schemas.openxmlformats.org/presentationml/2006/main">
+  <p:cSld>
+    <p:spTree>
+      <p:nvGrpSpPr>
+        <p:cNvPr id="1" name="">
+          <a:extLst>
+            <a:ext uri="{FF2B5EF4-FFF2-40B4-BE49-F238E27FC236}">
+              <a16:creationId xmlns:a16="http://schemas.microsoft.com/office/drawing/2014/main" id="{4553FC70-AEFC-4104-8C4A-9E6893A0A19B}"/>
+            </a:ext>
+          </a:extLst>
+        </p:cNvPr>
+        <p:cNvGrpSpPr/>
+        <p:nvPr/>
+      </p:nvGrpSpPr>
+      <p:grpSpPr>
+        <a:xfrm>
+          <a:off x="0" y="0"/>
+          <a:ext cx="0" cy="0"/>
+          <a:chOff x="0" y="0"/>
+          <a:chExt cx="0" cy="0"/>
+        </a:xfrm>
+      </p:grpSpPr>
+      <p:graphicFrame>
+        <p:nvGraphicFramePr>
+          <p:cNvPr id="5" name="Table 4">
+            <a:extLst>
+              <a:ext uri="{FF2B5EF4-FFF2-40B4-BE49-F238E27FC236}">
+                <a16:creationId xmlns:a16="http://schemas.microsoft.com/office/drawing/2014/main" id="{CB2D7609-3810-6239-20E6-C0E083CFC115}"/>
+              </a:ext>
+            </a:extLst>
+          </p:cNvPr>
+          <p:cNvGraphicFramePr>
+            <a:graphicFrameLocks noGrp="1"/>
+          </p:cNvGraphicFramePr>
+          <p:nvPr>
+            <p:extLst>
+              <p:ext uri="{D42A27DB-BD31-4B8C-83A1-F6EECF244321}">
+                <p14:modId xmlns:p14="http://schemas.microsoft.com/office/powerpoint/2010/main" val="335261080"/>
+              </p:ext>
+            </p:extLst>
+          </p:nvPr>
+        </p:nvGraphicFramePr>
+        <p:xfrm>
+          <a:off x="1883664" y="260341"/>
+          <a:ext cx="8705088" cy="6519673"/>
+        </p:xfrm>
+        <a:graphic>
+          <a:graphicData uri="http://schemas.openxmlformats.org/drawingml/2006/table">
+            <a:tbl>
+              <a:tblPr>
+                <a:tableStyleId>{2D5ABB26-0587-4C30-8999-92F81FD0307C}</a:tableStyleId>
+              </a:tblPr>
+              <a:tblGrid>
+                <a:gridCol w="2901696">
+                  <a:extLst>
+                    <a:ext uri="{9D8B030D-6E8A-4147-A177-3AD203B41FA5}">
+                      <a16:colId xmlns:a16="http://schemas.microsoft.com/office/drawing/2014/main" val="2115971656"/>
+                    </a:ext>
+                  </a:extLst>
+                </a:gridCol>
+                <a:gridCol w="2901696">
+                  <a:extLst>
+                    <a:ext uri="{9D8B030D-6E8A-4147-A177-3AD203B41FA5}">
+                      <a16:colId xmlns:a16="http://schemas.microsoft.com/office/drawing/2014/main" val="1695238265"/>
+                    </a:ext>
+                  </a:extLst>
+                </a:gridCol>
+                <a:gridCol w="2901696">
+                  <a:extLst>
+                    <a:ext uri="{9D8B030D-6E8A-4147-A177-3AD203B41FA5}">
+                      <a16:colId xmlns:a16="http://schemas.microsoft.com/office/drawing/2014/main" val="3765747969"/>
+                    </a:ext>
+                  </a:extLst>
+                </a:gridCol>
+              </a:tblGrid>
+              <a:tr h="931382">
+                <a:tc>
+                  <a:txBody>
+                    <a:bodyPr/>
+                    <a:lstStyle/>
+                    <a:p>
+                      <a:endParaRPr lang="en-US" dirty="0"/>
+                    </a:p>
+                  </a:txBody>
+                  <a:tcPr>
+                    <a:lnL w="12700" cap="flat" cmpd="sng" algn="ctr">
+                      <a:solidFill>
+                        <a:schemeClr val="tx1"/>
+                      </a:solidFill>
+                      <a:prstDash val="solid"/>
+                      <a:round/>
+                      <a:headEnd type="none" w="med" len="med"/>
+                      <a:tailEnd type="none" w="med" len="med"/>
+                    </a:lnL>
+                    <a:lnR w="12700" cap="flat" cmpd="sng" algn="ctr">
+                      <a:solidFill>
+                        <a:schemeClr val="tx1"/>
+                      </a:solidFill>
+                      <a:prstDash val="sysDash"/>
+                      <a:round/>
+                      <a:headEnd type="none" w="med" len="med"/>
+                      <a:tailEnd type="none" w="med" len="med"/>
+                    </a:lnR>
+                    <a:lnT w="12700" cap="flat" cmpd="sng" algn="ctr">
+                      <a:solidFill>
+                        <a:schemeClr val="tx1"/>
+                      </a:solidFill>
+                      <a:prstDash val="solid"/>
+                      <a:round/>
+                      <a:headEnd type="none" w="med" len="med"/>
+                      <a:tailEnd type="none" w="med" len="med"/>
+                    </a:lnT>
+                    <a:lnB w="12700" cap="flat" cmpd="sng" algn="ctr">
+                      <a:solidFill>
+                        <a:schemeClr val="tx1"/>
+                      </a:solidFill>
+                      <a:prstDash val="solid"/>
+                      <a:round/>
+                      <a:headEnd type="none" w="med" len="med"/>
+                      <a:tailEnd type="none" w="med" len="med"/>
+                    </a:lnB>
+                  </a:tcPr>
+                </a:tc>
+                <a:tc>
+                  <a:txBody>
+                    <a:bodyPr/>
+                    <a:lstStyle/>
+                    <a:p>
+                      <a:endParaRPr lang="en-US" dirty="0"/>
+                    </a:p>
+                  </a:txBody>
+                  <a:tcPr>
+                    <a:lnL w="12700" cap="flat" cmpd="sng" algn="ctr">
+                      <a:solidFill>
+                        <a:schemeClr val="tx1"/>
+                      </a:solidFill>
+                      <a:prstDash val="sysDash"/>
+                      <a:round/>
+                      <a:headEnd type="none" w="med" len="med"/>
+                      <a:tailEnd type="none" w="med" len="med"/>
+                    </a:lnL>
+                    <a:lnR w="12700" cap="flat" cmpd="sng" algn="ctr">
+                      <a:solidFill>
+                        <a:schemeClr val="tx1"/>
+                      </a:solidFill>
+                      <a:prstDash val="sysDash"/>
+                      <a:round/>
+                      <a:headEnd type="none" w="med" len="med"/>
+                      <a:tailEnd type="none" w="med" len="med"/>
+                    </a:lnR>
+                    <a:lnT w="12700" cap="flat" cmpd="sng" algn="ctr">
+                      <a:solidFill>
+                        <a:schemeClr val="tx1"/>
+                      </a:solidFill>
+                      <a:prstDash val="solid"/>
+                      <a:round/>
+                      <a:headEnd type="none" w="med" len="med"/>
+                      <a:tailEnd type="none" w="med" len="med"/>
+                    </a:lnT>
+                    <a:lnB w="12700" cap="flat" cmpd="sng" algn="ctr">
+                      <a:solidFill>
+                        <a:schemeClr val="tx1"/>
+                      </a:solidFill>
+                      <a:prstDash val="solid"/>
+                      <a:round/>
+                      <a:headEnd type="none" w="med" len="med"/>
+                      <a:tailEnd type="none" w="med" len="med"/>
+                    </a:lnB>
+                  </a:tcPr>
+                </a:tc>
+                <a:tc>
+                  <a:txBody>
+                    <a:bodyPr/>
+                    <a:lstStyle/>
+                    <a:p>
+                      <a:endParaRPr lang="en-US" dirty="0"/>
+                    </a:p>
+                  </a:txBody>
+                  <a:tcPr>
+                    <a:lnL w="12700" cap="flat" cmpd="sng" algn="ctr">
+                      <a:solidFill>
+                        <a:schemeClr val="tx1"/>
+                      </a:solidFill>
+                      <a:prstDash val="sysDash"/>
+                      <a:round/>
+                      <a:headEnd type="none" w="med" len="med"/>
+                      <a:tailEnd type="none" w="med" len="med"/>
+                    </a:lnL>
+                    <a:lnR w="12700" cap="flat" cmpd="sng" algn="ctr">
+                      <a:solidFill>
+                        <a:schemeClr val="tx1"/>
+                      </a:solidFill>
+                      <a:prstDash val="solid"/>
+                      <a:round/>
+                      <a:headEnd type="none" w="med" len="med"/>
+                      <a:tailEnd type="none" w="med" len="med"/>
+                    </a:lnR>
+                    <a:lnT w="12700" cap="flat" cmpd="sng" algn="ctr">
+                      <a:solidFill>
+                        <a:schemeClr val="tx1"/>
+                      </a:solidFill>
+                      <a:prstDash val="solid"/>
+                      <a:round/>
+                      <a:headEnd type="none" w="med" len="med"/>
+                      <a:tailEnd type="none" w="med" len="med"/>
+                    </a:lnT>
+                    <a:lnB w="12700" cap="flat" cmpd="sng" algn="ctr">
+                      <a:solidFill>
+                        <a:schemeClr val="tx1"/>
+                      </a:solidFill>
+                      <a:prstDash val="solid"/>
+                      <a:round/>
+                      <a:headEnd type="none" w="med" len="med"/>
+                      <a:tailEnd type="none" w="med" len="med"/>
+                    </a:lnB>
+                  </a:tcPr>
+                </a:tc>
+                <a:extLst>
+                  <a:ext uri="{0D108BD9-81ED-4DB2-BD59-A6C34878D82A}">
+                    <a16:rowId xmlns:a16="http://schemas.microsoft.com/office/drawing/2014/main" val="2257803333"/>
+                  </a:ext>
+                </a:extLst>
+              </a:tr>
+              <a:tr h="931382">
+                <a:tc>
+                  <a:txBody>
+                    <a:bodyPr/>
+                    <a:lstStyle/>
+                    <a:p>
+                      <a:endParaRPr lang="en-US" dirty="0"/>
+                    </a:p>
+                  </a:txBody>
+                  <a:tcPr>
+                    <a:lnL w="12700" cap="flat" cmpd="sng" algn="ctr">
+                      <a:solidFill>
+                        <a:schemeClr val="tx1"/>
+                      </a:solidFill>
+                      <a:prstDash val="solid"/>
+                      <a:round/>
+                      <a:headEnd type="none" w="med" len="med"/>
+                      <a:tailEnd type="none" w="med" len="med"/>
+                    </a:lnL>
+                    <a:lnR w="12700" cap="flat" cmpd="sng" algn="ctr">
+                      <a:solidFill>
+                        <a:schemeClr val="tx1"/>
+                      </a:solidFill>
+                      <a:prstDash val="sysDash"/>
+                      <a:round/>
+                      <a:headEnd type="none" w="med" len="med"/>
+                      <a:tailEnd type="none" w="med" len="med"/>
+                    </a:lnR>
+                    <a:lnT w="12700" cap="flat" cmpd="sng" algn="ctr">
+                      <a:solidFill>
+                        <a:schemeClr val="tx1"/>
+                      </a:solidFill>
+                      <a:prstDash val="solid"/>
+                      <a:round/>
+                      <a:headEnd type="none" w="med" len="med"/>
+                      <a:tailEnd type="none" w="med" len="med"/>
+                    </a:lnT>
+                    <a:lnB w="12700" cap="flat" cmpd="sng" algn="ctr">
+                      <a:solidFill>
+                        <a:schemeClr val="tx1"/>
+                      </a:solidFill>
+                      <a:prstDash val="solid"/>
+                      <a:round/>
+                      <a:headEnd type="none" w="med" len="med"/>
+                      <a:tailEnd type="none" w="med" len="med"/>
+                    </a:lnB>
+                  </a:tcPr>
+                </a:tc>
+                <a:tc>
+                  <a:txBody>
+                    <a:bodyPr/>
+                    <a:lstStyle/>
+                    <a:p>
+                      <a:endParaRPr lang="en-US" dirty="0"/>
+                    </a:p>
+                  </a:txBody>
+                  <a:tcPr>
+                    <a:lnL w="12700" cap="flat" cmpd="sng" algn="ctr">
+                      <a:solidFill>
+                        <a:schemeClr val="tx1"/>
+                      </a:solidFill>
+                      <a:prstDash val="sysDash"/>
+                      <a:round/>
+                      <a:headEnd type="none" w="med" len="med"/>
+                      <a:tailEnd type="none" w="med" len="med"/>
+                    </a:lnL>
+                    <a:lnR w="12700" cap="flat" cmpd="sng" algn="ctr">
+                      <a:solidFill>
+                        <a:schemeClr val="tx1"/>
+                      </a:solidFill>
+                      <a:prstDash val="sysDash"/>
+                      <a:round/>
+                      <a:headEnd type="none" w="med" len="med"/>
+                      <a:tailEnd type="none" w="med" len="med"/>
+                    </a:lnR>
+                    <a:lnT w="12700" cap="flat" cmpd="sng" algn="ctr">
+                      <a:solidFill>
+                        <a:schemeClr val="tx1"/>
+                      </a:solidFill>
+                      <a:prstDash val="solid"/>
+                      <a:round/>
+                      <a:headEnd type="none" w="med" len="med"/>
+                      <a:tailEnd type="none" w="med" len="med"/>
+                    </a:lnT>
+                    <a:lnB w="12700" cap="flat" cmpd="sng" algn="ctr">
+                      <a:solidFill>
+                        <a:schemeClr val="tx1"/>
+                      </a:solidFill>
+                      <a:prstDash val="solid"/>
+                      <a:round/>
+                      <a:headEnd type="none" w="med" len="med"/>
+                      <a:tailEnd type="none" w="med" len="med"/>
+                    </a:lnB>
+                  </a:tcPr>
+                </a:tc>
+                <a:tc>
+                  <a:txBody>
+                    <a:bodyPr/>
+                    <a:lstStyle/>
+                    <a:p>
+                      <a:endParaRPr lang="en-US" dirty="0"/>
+                    </a:p>
+                  </a:txBody>
+                  <a:tcPr>
+                    <a:lnL w="12700" cap="flat" cmpd="sng" algn="ctr">
+                      <a:solidFill>
+                        <a:schemeClr val="tx1"/>
+                      </a:solidFill>
+                      <a:prstDash val="sysDash"/>
+                      <a:round/>
+                      <a:headEnd type="none" w="med" len="med"/>
+                      <a:tailEnd type="none" w="med" len="med"/>
+                    </a:lnL>
+                    <a:lnR w="12700" cap="flat" cmpd="sng" algn="ctr">
+                      <a:solidFill>
+                        <a:schemeClr val="tx1"/>
+                      </a:solidFill>
+                      <a:prstDash val="solid"/>
+                      <a:round/>
+                      <a:headEnd type="none" w="med" len="med"/>
+                      <a:tailEnd type="none" w="med" len="med"/>
+                    </a:lnR>
+                    <a:lnT w="12700" cap="flat" cmpd="sng" algn="ctr">
+                      <a:solidFill>
+                        <a:schemeClr val="tx1"/>
+                      </a:solidFill>
+                      <a:prstDash val="solid"/>
+                      <a:round/>
+                      <a:headEnd type="none" w="med" len="med"/>
+                      <a:tailEnd type="none" w="med" len="med"/>
+                    </a:lnT>
+                    <a:lnB w="12700" cap="flat" cmpd="sng" algn="ctr">
+                      <a:solidFill>
+                        <a:schemeClr val="tx1"/>
+                      </a:solidFill>
+                      <a:prstDash val="solid"/>
+                      <a:round/>
+                      <a:headEnd type="none" w="med" len="med"/>
+                      <a:tailEnd type="none" w="med" len="med"/>
+                    </a:lnB>
+                  </a:tcPr>
+                </a:tc>
+                <a:extLst>
+                  <a:ext uri="{0D108BD9-81ED-4DB2-BD59-A6C34878D82A}">
+                    <a16:rowId xmlns:a16="http://schemas.microsoft.com/office/drawing/2014/main" val="1794028559"/>
+                  </a:ext>
+                </a:extLst>
+              </a:tr>
+              <a:tr h="931382">
+                <a:tc>
+                  <a:txBody>
+                    <a:bodyPr/>
+                    <a:lstStyle/>
+                    <a:p>
+                      <a:endParaRPr lang="en-US" dirty="0"/>
+                    </a:p>
+                  </a:txBody>
+                  <a:tcPr>
+                    <a:lnL w="12700" cap="flat" cmpd="sng" algn="ctr">
+                      <a:solidFill>
+                        <a:schemeClr val="tx1"/>
+                      </a:solidFill>
+                      <a:prstDash val="solid"/>
+                      <a:round/>
+                      <a:headEnd type="none" w="med" len="med"/>
+                      <a:tailEnd type="none" w="med" len="med"/>
+                    </a:lnL>
+                    <a:lnR w="12700" cap="flat" cmpd="sng" algn="ctr">
+                      <a:solidFill>
+                        <a:schemeClr val="tx1"/>
+                      </a:solidFill>
+                      <a:prstDash val="sysDash"/>
+                      <a:round/>
+                      <a:headEnd type="none" w="med" len="med"/>
+                      <a:tailEnd type="none" w="med" len="med"/>
+                    </a:lnR>
+                    <a:lnT w="12700" cap="flat" cmpd="sng" algn="ctr">
+                      <a:solidFill>
+                        <a:schemeClr val="tx1"/>
+                      </a:solidFill>
+                      <a:prstDash val="solid"/>
+                      <a:round/>
+                      <a:headEnd type="none" w="med" len="med"/>
+                      <a:tailEnd type="none" w="med" len="med"/>
+                    </a:lnT>
+                    <a:lnB w="12700" cap="flat" cmpd="sng" algn="ctr">
+                      <a:solidFill>
+                        <a:schemeClr val="tx1"/>
+                      </a:solidFill>
+                      <a:prstDash val="solid"/>
+                      <a:round/>
+                      <a:headEnd type="none" w="med" len="med"/>
+                      <a:tailEnd type="none" w="med" len="med"/>
+                    </a:lnB>
+                  </a:tcPr>
+                </a:tc>
+                <a:tc>
+                  <a:txBody>
+                    <a:bodyPr/>
+                    <a:lstStyle/>
+                    <a:p>
+                      <a:endParaRPr lang="en-US" dirty="0"/>
+                    </a:p>
+                  </a:txBody>
+                  <a:tcPr>
+                    <a:lnL w="12700" cap="flat" cmpd="sng" algn="ctr">
+                      <a:solidFill>
+                        <a:schemeClr val="tx1"/>
+                      </a:solidFill>
+                      <a:prstDash val="sysDash"/>
+                      <a:round/>
+                      <a:headEnd type="none" w="med" len="med"/>
+                      <a:tailEnd type="none" w="med" len="med"/>
+                    </a:lnL>
+                    <a:lnR w="12700" cap="flat" cmpd="sng" algn="ctr">
+                      <a:solidFill>
+                        <a:schemeClr val="tx1"/>
+                      </a:solidFill>
+                      <a:prstDash val="sysDash"/>
+                      <a:round/>
+                      <a:headEnd type="none" w="med" len="med"/>
+                      <a:tailEnd type="none" w="med" len="med"/>
+                    </a:lnR>
+                    <a:lnT w="12700" cap="flat" cmpd="sng" algn="ctr">
+                      <a:solidFill>
+                        <a:schemeClr val="tx1"/>
+                      </a:solidFill>
+                      <a:prstDash val="solid"/>
+                      <a:round/>
+                      <a:headEnd type="none" w="med" len="med"/>
+                      <a:tailEnd type="none" w="med" len="med"/>
+                    </a:lnT>
+                    <a:lnB w="12700" cap="flat" cmpd="sng" algn="ctr">
+                      <a:solidFill>
+                        <a:schemeClr val="tx1"/>
+                      </a:solidFill>
+                      <a:prstDash val="solid"/>
+                      <a:round/>
+                      <a:headEnd type="none" w="med" len="med"/>
+                      <a:tailEnd type="none" w="med" len="med"/>
+                    </a:lnB>
+                  </a:tcPr>
+                </a:tc>
+                <a:tc>
+                  <a:txBody>
+                    <a:bodyPr/>
+                    <a:lstStyle/>
+                    <a:p>
+                      <a:endParaRPr lang="en-US" dirty="0"/>
+                    </a:p>
+                  </a:txBody>
+                  <a:tcPr>
+                    <a:lnL w="12700" cap="flat" cmpd="sng" algn="ctr">
+                      <a:solidFill>
+                        <a:schemeClr val="tx1"/>
+                      </a:solidFill>
+                      <a:prstDash val="sysDash"/>
+                      <a:round/>
+                      <a:headEnd type="none" w="med" len="med"/>
+                      <a:tailEnd type="none" w="med" len="med"/>
+                    </a:lnL>
+                    <a:lnR w="12700" cap="flat" cmpd="sng" algn="ctr">
+                      <a:solidFill>
+                        <a:schemeClr val="tx1"/>
+                      </a:solidFill>
+                      <a:prstDash val="solid"/>
+                      <a:round/>
+                      <a:headEnd type="none" w="med" len="med"/>
+                      <a:tailEnd type="none" w="med" len="med"/>
+                    </a:lnR>
+                    <a:lnT w="12700" cap="flat" cmpd="sng" algn="ctr">
+                      <a:solidFill>
+                        <a:schemeClr val="tx1"/>
+                      </a:solidFill>
+                      <a:prstDash val="solid"/>
+                      <a:round/>
+                      <a:headEnd type="none" w="med" len="med"/>
+                      <a:tailEnd type="none" w="med" len="med"/>
+                    </a:lnT>
+                    <a:lnB w="12700" cap="flat" cmpd="sng" algn="ctr">
+                      <a:solidFill>
+                        <a:schemeClr val="tx1"/>
+                      </a:solidFill>
+                      <a:prstDash val="solid"/>
+                      <a:round/>
+                      <a:headEnd type="none" w="med" len="med"/>
+                      <a:tailEnd type="none" w="med" len="med"/>
+                    </a:lnB>
+                  </a:tcPr>
+                </a:tc>
+                <a:extLst>
+                  <a:ext uri="{0D108BD9-81ED-4DB2-BD59-A6C34878D82A}">
+                    <a16:rowId xmlns:a16="http://schemas.microsoft.com/office/drawing/2014/main" val="947632794"/>
+                  </a:ext>
+                </a:extLst>
+              </a:tr>
+              <a:tr h="931381">
+                <a:tc>
+                  <a:txBody>
+                    <a:bodyPr/>
+                    <a:lstStyle/>
+                    <a:p>
+                      <a:endParaRPr lang="en-US" dirty="0"/>
+                    </a:p>
+                  </a:txBody>
+                  <a:tcPr>
+                    <a:lnL w="12700" cap="flat" cmpd="sng" algn="ctr">
+                      <a:solidFill>
+                        <a:schemeClr val="tx1"/>
+                      </a:solidFill>
+                      <a:prstDash val="solid"/>
+                      <a:round/>
+                      <a:headEnd type="none" w="med" len="med"/>
+                      <a:tailEnd type="none" w="med" len="med"/>
+                    </a:lnL>
+                    <a:lnR w="12700" cap="flat" cmpd="sng" algn="ctr">
+                      <a:solidFill>
+                        <a:schemeClr val="tx1"/>
+                      </a:solidFill>
+                      <a:prstDash val="sysDash"/>
+                      <a:round/>
+                      <a:headEnd type="none" w="med" len="med"/>
+                      <a:tailEnd type="none" w="med" len="med"/>
+                    </a:lnR>
+                    <a:lnT w="12700" cap="flat" cmpd="sng" algn="ctr">
+                      <a:solidFill>
+                        <a:schemeClr val="tx1"/>
+                      </a:solidFill>
+                      <a:prstDash val="solid"/>
+                      <a:round/>
+                      <a:headEnd type="none" w="med" len="med"/>
+                      <a:tailEnd type="none" w="med" len="med"/>
+                    </a:lnT>
+                    <a:lnB w="12700" cap="flat" cmpd="sng" algn="ctr">
+                      <a:solidFill>
+                        <a:schemeClr val="tx1"/>
+                      </a:solidFill>
+                      <a:prstDash val="solid"/>
+                      <a:round/>
+                      <a:headEnd type="none" w="med" len="med"/>
+                      <a:tailEnd type="none" w="med" len="med"/>
+                    </a:lnB>
+                  </a:tcPr>
+                </a:tc>
+                <a:tc>
+                  <a:txBody>
+                    <a:bodyPr/>
+                    <a:lstStyle/>
+                    <a:p>
+                      <a:endParaRPr lang="en-US" dirty="0"/>
+                    </a:p>
+                  </a:txBody>
+                  <a:tcPr>
+                    <a:lnL w="12700" cap="flat" cmpd="sng" algn="ctr">
+                      <a:solidFill>
+                        <a:schemeClr val="tx1"/>
+                      </a:solidFill>
+                      <a:prstDash val="sysDash"/>
+                      <a:round/>
+                      <a:headEnd type="none" w="med" len="med"/>
+                      <a:tailEnd type="none" w="med" len="med"/>
+                    </a:lnL>
+                    <a:lnR w="12700" cap="flat" cmpd="sng" algn="ctr">
+                      <a:solidFill>
+                        <a:schemeClr val="tx1"/>
+                      </a:solidFill>
+                      <a:prstDash val="sysDash"/>
+                      <a:round/>
+                      <a:headEnd type="none" w="med" len="med"/>
+                      <a:tailEnd type="none" w="med" len="med"/>
+                    </a:lnR>
+                    <a:lnT w="12700" cap="flat" cmpd="sng" algn="ctr">
+                      <a:solidFill>
+                        <a:schemeClr val="tx1"/>
+                      </a:solidFill>
+                      <a:prstDash val="solid"/>
+                      <a:round/>
+                      <a:headEnd type="none" w="med" len="med"/>
+                      <a:tailEnd type="none" w="med" len="med"/>
+                    </a:lnT>
+                    <a:lnB w="12700" cap="flat" cmpd="sng" algn="ctr">
+                      <a:solidFill>
+                        <a:schemeClr val="tx1"/>
+                      </a:solidFill>
+                      <a:prstDash val="solid"/>
+                      <a:round/>
+                      <a:headEnd type="none" w="med" len="med"/>
+                      <a:tailEnd type="none" w="med" len="med"/>
+                    </a:lnB>
+                  </a:tcPr>
+                </a:tc>
+                <a:tc>
+                  <a:txBody>
+                    <a:bodyPr/>
+                    <a:lstStyle/>
+                    <a:p>
+                      <a:endParaRPr lang="en-US" dirty="0"/>
+                    </a:p>
+                  </a:txBody>
+                  <a:tcPr>
+                    <a:lnL w="12700" cap="flat" cmpd="sng" algn="ctr">
+                      <a:solidFill>
+                        <a:schemeClr val="tx1"/>
+                      </a:solidFill>
+                      <a:prstDash val="sysDash"/>
+                      <a:round/>
+                      <a:headEnd type="none" w="med" len="med"/>
+                      <a:tailEnd type="none" w="med" len="med"/>
+                    </a:lnL>
+                    <a:lnR w="12700" cap="flat" cmpd="sng" algn="ctr">
+                      <a:solidFill>
+                        <a:schemeClr val="tx1"/>
+                      </a:solidFill>
+                      <a:prstDash val="solid"/>
+                      <a:round/>
+                      <a:headEnd type="none" w="med" len="med"/>
+                      <a:tailEnd type="none" w="med" len="med"/>
+                    </a:lnR>
+                    <a:lnT w="12700" cap="flat" cmpd="sng" algn="ctr">
+                      <a:solidFill>
+                        <a:schemeClr val="tx1"/>
+                      </a:solidFill>
+                      <a:prstDash val="solid"/>
+                      <a:round/>
+                      <a:headEnd type="none" w="med" len="med"/>
+                      <a:tailEnd type="none" w="med" len="med"/>
+                    </a:lnT>
+                    <a:lnB w="12700" cap="flat" cmpd="sng" algn="ctr">
+                      <a:solidFill>
+                        <a:schemeClr val="tx1"/>
+                      </a:solidFill>
+                      <a:prstDash val="solid"/>
+                      <a:round/>
+                      <a:headEnd type="none" w="med" len="med"/>
+                      <a:tailEnd type="none" w="med" len="med"/>
+                    </a:lnB>
+                  </a:tcPr>
+                </a:tc>
+                <a:extLst>
+                  <a:ext uri="{0D108BD9-81ED-4DB2-BD59-A6C34878D82A}">
+                    <a16:rowId xmlns:a16="http://schemas.microsoft.com/office/drawing/2014/main" val="121631567"/>
+                  </a:ext>
+                </a:extLst>
+              </a:tr>
+              <a:tr h="931382">
+                <a:tc>
+                  <a:txBody>
+                    <a:bodyPr/>
+                    <a:lstStyle/>
+                    <a:p>
+                      <a:endParaRPr lang="en-US" dirty="0"/>
+                    </a:p>
+                  </a:txBody>
+                  <a:tcPr>
+                    <a:lnL w="12700" cap="flat" cmpd="sng" algn="ctr">
+                      <a:solidFill>
+                        <a:schemeClr val="tx1"/>
+                      </a:solidFill>
+                      <a:prstDash val="solid"/>
+                      <a:round/>
+                      <a:headEnd type="none" w="med" len="med"/>
+                      <a:tailEnd type="none" w="med" len="med"/>
+                    </a:lnL>
+                    <a:lnR w="12700" cap="flat" cmpd="sng" algn="ctr">
+                      <a:solidFill>
+                        <a:schemeClr val="tx1"/>
+                      </a:solidFill>
+                      <a:prstDash val="sysDash"/>
+                      <a:round/>
+                      <a:headEnd type="none" w="med" len="med"/>
+                      <a:tailEnd type="none" w="med" len="med"/>
+                    </a:lnR>
+                    <a:lnT w="12700" cap="flat" cmpd="sng" algn="ctr">
+                      <a:solidFill>
+                        <a:schemeClr val="tx1"/>
+                      </a:solidFill>
+                      <a:prstDash val="solid"/>
+                      <a:round/>
+                      <a:headEnd type="none" w="med" len="med"/>
+                      <a:tailEnd type="none" w="med" len="med"/>
+                    </a:lnT>
+                    <a:lnB w="12700" cap="flat" cmpd="sng" algn="ctr">
+                      <a:solidFill>
+                        <a:schemeClr val="tx1"/>
+                      </a:solidFill>
+                      <a:prstDash val="solid"/>
+                      <a:round/>
+                      <a:headEnd type="none" w="med" len="med"/>
+                      <a:tailEnd type="none" w="med" len="med"/>
+                    </a:lnB>
+                  </a:tcPr>
+                </a:tc>
+                <a:tc>
+                  <a:txBody>
+                    <a:bodyPr/>
+                    <a:lstStyle/>
+                    <a:p>
+                      <a:endParaRPr lang="en-US" dirty="0"/>
+                    </a:p>
+                  </a:txBody>
+                  <a:tcPr>
+                    <a:lnL w="12700" cap="flat" cmpd="sng" algn="ctr">
+                      <a:solidFill>
+                        <a:schemeClr val="tx1"/>
+                      </a:solidFill>
+                      <a:prstDash val="sysDash"/>
+                      <a:round/>
+                      <a:headEnd type="none" w="med" len="med"/>
+                      <a:tailEnd type="none" w="med" len="med"/>
+                    </a:lnL>
+                    <a:lnR w="12700" cap="flat" cmpd="sng" algn="ctr">
+                      <a:solidFill>
+                        <a:schemeClr val="tx1"/>
+                      </a:solidFill>
+                      <a:prstDash val="sysDash"/>
+                      <a:round/>
+                      <a:headEnd type="none" w="med" len="med"/>
+                      <a:tailEnd type="none" w="med" len="med"/>
+                    </a:lnR>
+                    <a:lnT w="12700" cap="flat" cmpd="sng" algn="ctr">
+                      <a:solidFill>
+                        <a:schemeClr val="tx1"/>
+                      </a:solidFill>
+                      <a:prstDash val="solid"/>
+                      <a:round/>
+                      <a:headEnd type="none" w="med" len="med"/>
+                      <a:tailEnd type="none" w="med" len="med"/>
+                    </a:lnT>
+                    <a:lnB w="12700" cap="flat" cmpd="sng" algn="ctr">
+                      <a:solidFill>
+                        <a:schemeClr val="tx1"/>
+                      </a:solidFill>
+                      <a:prstDash val="solid"/>
+                      <a:round/>
+                      <a:headEnd type="none" w="med" len="med"/>
+                      <a:tailEnd type="none" w="med" len="med"/>
+                    </a:lnB>
+                  </a:tcPr>
+                </a:tc>
+                <a:tc>
+                  <a:txBody>
+                    <a:bodyPr/>
+                    <a:lstStyle/>
+                    <a:p>
+                      <a:endParaRPr lang="en-US" dirty="0"/>
+                    </a:p>
+                  </a:txBody>
+                  <a:tcPr>
+                    <a:lnL w="12700" cap="flat" cmpd="sng" algn="ctr">
+                      <a:solidFill>
+                        <a:schemeClr val="tx1"/>
+                      </a:solidFill>
+                      <a:prstDash val="sysDash"/>
+                      <a:round/>
+                      <a:headEnd type="none" w="med" len="med"/>
+                      <a:tailEnd type="none" w="med" len="med"/>
+                    </a:lnL>
+                    <a:lnR w="12700" cap="flat" cmpd="sng" algn="ctr">
+                      <a:solidFill>
+                        <a:schemeClr val="tx1"/>
+                      </a:solidFill>
+                      <a:prstDash val="solid"/>
+                      <a:round/>
+                      <a:headEnd type="none" w="med" len="med"/>
+                      <a:tailEnd type="none" w="med" len="med"/>
+                    </a:lnR>
+                    <a:lnT w="12700" cap="flat" cmpd="sng" algn="ctr">
+                      <a:solidFill>
+                        <a:schemeClr val="tx1"/>
+                      </a:solidFill>
+                      <a:prstDash val="solid"/>
+                      <a:round/>
+                      <a:headEnd type="none" w="med" len="med"/>
+                      <a:tailEnd type="none" w="med" len="med"/>
+                    </a:lnT>
+                    <a:lnB w="12700" cap="flat" cmpd="sng" algn="ctr">
+                      <a:solidFill>
+                        <a:schemeClr val="tx1"/>
+                      </a:solidFill>
+                      <a:prstDash val="solid"/>
+                      <a:round/>
+                      <a:headEnd type="none" w="med" len="med"/>
+                      <a:tailEnd type="none" w="med" len="med"/>
+                    </a:lnB>
+                  </a:tcPr>
+                </a:tc>
+                <a:extLst>
+                  <a:ext uri="{0D108BD9-81ED-4DB2-BD59-A6C34878D82A}">
+                    <a16:rowId xmlns:a16="http://schemas.microsoft.com/office/drawing/2014/main" val="1347574895"/>
+                  </a:ext>
+                </a:extLst>
+              </a:tr>
+              <a:tr h="931382">
+                <a:tc>
+                  <a:txBody>
+                    <a:bodyPr/>
+                    <a:lstStyle/>
+                    <a:p>
+                      <a:endParaRPr lang="en-US" dirty="0"/>
+                    </a:p>
+                  </a:txBody>
+                  <a:tcPr>
+                    <a:lnL w="12700" cap="flat" cmpd="sng" algn="ctr">
+                      <a:solidFill>
+                        <a:schemeClr val="tx1"/>
+                      </a:solidFill>
+                      <a:prstDash val="solid"/>
+                      <a:round/>
+                      <a:headEnd type="none" w="med" len="med"/>
+                      <a:tailEnd type="none" w="med" len="med"/>
+                    </a:lnL>
+                    <a:lnR w="12700" cap="flat" cmpd="sng" algn="ctr">
+                      <a:solidFill>
+                        <a:schemeClr val="tx1"/>
+                      </a:solidFill>
+                      <a:prstDash val="sysDash"/>
+                      <a:round/>
+                      <a:headEnd type="none" w="med" len="med"/>
+                      <a:tailEnd type="none" w="med" len="med"/>
+                    </a:lnR>
+                    <a:lnT w="12700" cap="flat" cmpd="sng" algn="ctr">
+                      <a:solidFill>
+                        <a:schemeClr val="tx1"/>
+                      </a:solidFill>
+                      <a:prstDash val="solid"/>
+                      <a:round/>
+                      <a:headEnd type="none" w="med" len="med"/>
+                      <a:tailEnd type="none" w="med" len="med"/>
+                    </a:lnT>
+                    <a:lnB w="12700" cap="flat" cmpd="sng" algn="ctr">
+                      <a:solidFill>
+                        <a:schemeClr val="tx1"/>
+                      </a:solidFill>
+                      <a:prstDash val="solid"/>
+                      <a:round/>
+                      <a:headEnd type="none" w="med" len="med"/>
+                      <a:tailEnd type="none" w="med" len="med"/>
+                    </a:lnB>
+                  </a:tcPr>
+                </a:tc>
+                <a:tc>
+                  <a:txBody>
+                    <a:bodyPr/>
+                    <a:lstStyle/>
+                    <a:p>
+                      <a:endParaRPr lang="en-US" dirty="0"/>
+                    </a:p>
+                  </a:txBody>
+                  <a:tcPr>
+                    <a:lnL w="12700" cap="flat" cmpd="sng" algn="ctr">
+                      <a:solidFill>
+                        <a:schemeClr val="tx1"/>
+                      </a:solidFill>
+                      <a:prstDash val="sysDash"/>
+                      <a:round/>
+                      <a:headEnd type="none" w="med" len="med"/>
+                      <a:tailEnd type="none" w="med" len="med"/>
+                    </a:lnL>
+                    <a:lnR w="12700" cap="flat" cmpd="sng" algn="ctr">
+                      <a:solidFill>
+                        <a:schemeClr val="tx1"/>
+                      </a:solidFill>
+                      <a:prstDash val="sysDash"/>
+                      <a:round/>
+                      <a:headEnd type="none" w="med" len="med"/>
+                      <a:tailEnd type="none" w="med" len="med"/>
+                    </a:lnR>
+                    <a:lnT w="12700" cap="flat" cmpd="sng" algn="ctr">
+                      <a:solidFill>
+                        <a:schemeClr val="tx1"/>
+                      </a:solidFill>
+                      <a:prstDash val="solid"/>
+                      <a:round/>
+                      <a:headEnd type="none" w="med" len="med"/>
+                      <a:tailEnd type="none" w="med" len="med"/>
+                    </a:lnT>
+                    <a:lnB w="12700" cap="flat" cmpd="sng" algn="ctr">
+                      <a:solidFill>
+                        <a:schemeClr val="tx1"/>
+                      </a:solidFill>
+                      <a:prstDash val="solid"/>
+                      <a:round/>
+                      <a:headEnd type="none" w="med" len="med"/>
+                      <a:tailEnd type="none" w="med" len="med"/>
+                    </a:lnB>
+                  </a:tcPr>
+                </a:tc>
+                <a:tc>
+                  <a:txBody>
+                    <a:bodyPr/>
+                    <a:lstStyle/>
+                    <a:p>
+                      <a:endParaRPr lang="en-US" dirty="0"/>
+                    </a:p>
+                  </a:txBody>
+                  <a:tcPr>
+                    <a:lnL w="12700" cap="flat" cmpd="sng" algn="ctr">
+                      <a:solidFill>
+                        <a:schemeClr val="tx1"/>
+                      </a:solidFill>
+                      <a:prstDash val="sysDash"/>
+                      <a:round/>
+                      <a:headEnd type="none" w="med" len="med"/>
+                      <a:tailEnd type="none" w="med" len="med"/>
+                    </a:lnL>
+                    <a:lnR w="12700" cap="flat" cmpd="sng" algn="ctr">
+                      <a:solidFill>
+                        <a:schemeClr val="tx1"/>
+                      </a:solidFill>
+                      <a:prstDash val="solid"/>
+                      <a:round/>
+                      <a:headEnd type="none" w="med" len="med"/>
+                      <a:tailEnd type="none" w="med" len="med"/>
+                    </a:lnR>
+                    <a:lnT w="12700" cap="flat" cmpd="sng" algn="ctr">
+                      <a:solidFill>
+                        <a:schemeClr val="tx1"/>
+                      </a:solidFill>
+                      <a:prstDash val="solid"/>
+                      <a:round/>
+                      <a:headEnd type="none" w="med" len="med"/>
+                      <a:tailEnd type="none" w="med" len="med"/>
+                    </a:lnT>
+                    <a:lnB w="12700" cap="flat" cmpd="sng" algn="ctr">
+                      <a:solidFill>
+                        <a:schemeClr val="tx1"/>
+                      </a:solidFill>
+                      <a:prstDash val="solid"/>
+                      <a:round/>
+                      <a:headEnd type="none" w="med" len="med"/>
+                      <a:tailEnd type="none" w="med" len="med"/>
+                    </a:lnB>
+                  </a:tcPr>
+                </a:tc>
+                <a:extLst>
+                  <a:ext uri="{0D108BD9-81ED-4DB2-BD59-A6C34878D82A}">
+                    <a16:rowId xmlns:a16="http://schemas.microsoft.com/office/drawing/2014/main" val="1840204653"/>
+                  </a:ext>
+                </a:extLst>
+              </a:tr>
+              <a:tr h="931382">
+                <a:tc>
+                  <a:txBody>
+                    <a:bodyPr/>
+                    <a:lstStyle/>
+                    <a:p>
+                      <a:endParaRPr lang="en-US" dirty="0"/>
+                    </a:p>
+                  </a:txBody>
+                  <a:tcPr>
+                    <a:lnL w="12700" cap="flat" cmpd="sng" algn="ctr">
+                      <a:solidFill>
+                        <a:schemeClr val="tx1"/>
+                      </a:solidFill>
+                      <a:prstDash val="solid"/>
+                      <a:round/>
+                      <a:headEnd type="none" w="med" len="med"/>
+                      <a:tailEnd type="none" w="med" len="med"/>
+                    </a:lnL>
+                    <a:lnR w="12700" cap="flat" cmpd="sng" algn="ctr">
+                      <a:solidFill>
+                        <a:schemeClr val="tx1"/>
+                      </a:solidFill>
+                      <a:prstDash val="sysDash"/>
+                      <a:round/>
+                      <a:headEnd type="none" w="med" len="med"/>
+                      <a:tailEnd type="none" w="med" len="med"/>
+                    </a:lnR>
+                    <a:lnT w="12700" cap="flat" cmpd="sng" algn="ctr">
+                      <a:solidFill>
+                        <a:schemeClr val="tx1"/>
+                      </a:solidFill>
+                      <a:prstDash val="solid"/>
+                      <a:round/>
+                      <a:headEnd type="none" w="med" len="med"/>
+                      <a:tailEnd type="none" w="med" len="med"/>
+                    </a:lnT>
+                    <a:lnB w="12700" cap="flat" cmpd="sng" algn="ctr">
+                      <a:solidFill>
+                        <a:schemeClr val="tx1"/>
+                      </a:solidFill>
+                      <a:prstDash val="solid"/>
+                      <a:round/>
+                      <a:headEnd type="none" w="med" len="med"/>
+                      <a:tailEnd type="none" w="med" len="med"/>
+                    </a:lnB>
+                  </a:tcPr>
+                </a:tc>
+                <a:tc>
+                  <a:txBody>
+                    <a:bodyPr/>
+                    <a:lstStyle/>
+                    <a:p>
+                      <a:endParaRPr lang="en-US" dirty="0"/>
+                    </a:p>
+                  </a:txBody>
+                  <a:tcPr>
+                    <a:lnL w="12700" cap="flat" cmpd="sng" algn="ctr">
+                      <a:solidFill>
+                        <a:schemeClr val="tx1"/>
+                      </a:solidFill>
+                      <a:prstDash val="sysDash"/>
+                      <a:round/>
+                      <a:headEnd type="none" w="med" len="med"/>
+                      <a:tailEnd type="none" w="med" len="med"/>
+                    </a:lnL>
+                    <a:lnR w="12700" cap="flat" cmpd="sng" algn="ctr">
+                      <a:solidFill>
+                        <a:schemeClr val="tx1"/>
+                      </a:solidFill>
+                      <a:prstDash val="sysDash"/>
+                      <a:round/>
+                      <a:headEnd type="none" w="med" len="med"/>
+                      <a:tailEnd type="none" w="med" len="med"/>
+                    </a:lnR>
+                    <a:lnT w="12700" cap="flat" cmpd="sng" algn="ctr">
+                      <a:solidFill>
+                        <a:schemeClr val="tx1"/>
+                      </a:solidFill>
+                      <a:prstDash val="solid"/>
+                      <a:round/>
+                      <a:headEnd type="none" w="med" len="med"/>
+                      <a:tailEnd type="none" w="med" len="med"/>
+                    </a:lnT>
+                    <a:lnB w="12700" cap="flat" cmpd="sng" algn="ctr">
+                      <a:solidFill>
+                        <a:schemeClr val="tx1"/>
+                      </a:solidFill>
+                      <a:prstDash val="solid"/>
+                      <a:round/>
+                      <a:headEnd type="none" w="med" len="med"/>
+                      <a:tailEnd type="none" w="med" len="med"/>
+                    </a:lnB>
+                  </a:tcPr>
+                </a:tc>
+                <a:tc>
+                  <a:txBody>
+                    <a:bodyPr/>
+                    <a:lstStyle/>
+                    <a:p>
+                      <a:endParaRPr lang="en-US" dirty="0"/>
+                    </a:p>
+                  </a:txBody>
+                  <a:tcPr>
+                    <a:lnL w="12700" cap="flat" cmpd="sng" algn="ctr">
+                      <a:solidFill>
+                        <a:schemeClr val="tx1"/>
+                      </a:solidFill>
+                      <a:prstDash val="sysDash"/>
+                      <a:round/>
+                      <a:headEnd type="none" w="med" len="med"/>
+                      <a:tailEnd type="none" w="med" len="med"/>
+                    </a:lnL>
+                    <a:lnR w="12700" cap="flat" cmpd="sng" algn="ctr">
+                      <a:solidFill>
+                        <a:schemeClr val="tx1"/>
+                      </a:solidFill>
+                      <a:prstDash val="solid"/>
+                      <a:round/>
+                      <a:headEnd type="none" w="med" len="med"/>
+                      <a:tailEnd type="none" w="med" len="med"/>
+                    </a:lnR>
+                    <a:lnT w="12700" cap="flat" cmpd="sng" algn="ctr">
+                      <a:solidFill>
+                        <a:schemeClr val="tx1"/>
+                      </a:solidFill>
+                      <a:prstDash val="solid"/>
+                      <a:round/>
+                      <a:headEnd type="none" w="med" len="med"/>
+                      <a:tailEnd type="none" w="med" len="med"/>
+                    </a:lnT>
+                    <a:lnB w="12700" cap="flat" cmpd="sng" algn="ctr">
+                      <a:solidFill>
+                        <a:schemeClr val="tx1"/>
+                      </a:solidFill>
+                      <a:prstDash val="solid"/>
+                      <a:round/>
+                      <a:headEnd type="none" w="med" len="med"/>
+                      <a:tailEnd type="none" w="med" len="med"/>
+                    </a:lnB>
+                  </a:tcPr>
+                </a:tc>
+                <a:extLst>
+                  <a:ext uri="{0D108BD9-81ED-4DB2-BD59-A6C34878D82A}">
+                    <a16:rowId xmlns:a16="http://schemas.microsoft.com/office/drawing/2014/main" val="3767174255"/>
+                  </a:ext>
+                </a:extLst>
+              </a:tr>
+            </a:tbl>
+          </a:graphicData>
+        </a:graphic>
+      </p:graphicFrame>
+      <p:sp>
+        <p:nvSpPr>
+          <p:cNvPr id="6" name="TextBox 5">
+            <a:extLst>
+              <a:ext uri="{FF2B5EF4-FFF2-40B4-BE49-F238E27FC236}">
+                <a16:creationId xmlns:a16="http://schemas.microsoft.com/office/drawing/2014/main" id="{9E46FFC7-25A7-2F0C-083D-D6830D7B3D50}"/>
+              </a:ext>
+            </a:extLst>
+          </p:cNvPr>
+          <p:cNvSpPr txBox="1"/>
+          <p:nvPr/>
+        </p:nvSpPr>
+        <p:spPr>
+          <a:xfrm>
+            <a:off x="5586984" y="-30095"/>
+            <a:ext cx="1298448" cy="369332"/>
+          </a:xfrm>
+          <a:prstGeom prst="rect">
+            <a:avLst/>
+          </a:prstGeom>
+          <a:noFill/>
+        </p:spPr>
+        <p:txBody>
+          <a:bodyPr wrap="square" rtlCol="0">
+            <a:spAutoFit/>
+          </a:bodyPr>
+          <a:lstStyle/>
+          <a:p>
+            <a:pPr algn="ctr"/>
+            <a:r>
+              <a:rPr lang="en-US" dirty="0"/>
+              <a:t>Door</a:t>
+            </a:r>
+          </a:p>
+        </p:txBody>
+      </p:sp>
+      <p:sp>
+        <p:nvSpPr>
+          <p:cNvPr id="7" name="TextBox 6">
+            <a:extLst>
+              <a:ext uri="{FF2B5EF4-FFF2-40B4-BE49-F238E27FC236}">
+                <a16:creationId xmlns:a16="http://schemas.microsoft.com/office/drawing/2014/main" id="{3969FE0A-F9BC-ECB6-0DFB-57D121288FE8}"/>
+              </a:ext>
+            </a:extLst>
+          </p:cNvPr>
+          <p:cNvSpPr txBox="1"/>
+          <p:nvPr/>
+        </p:nvSpPr>
+        <p:spPr>
+          <a:xfrm>
+            <a:off x="5586984" y="6319504"/>
+            <a:ext cx="1298448" cy="369332"/>
+          </a:xfrm>
+          <a:prstGeom prst="rect">
+            <a:avLst/>
+          </a:prstGeom>
+          <a:noFill/>
+        </p:spPr>
+        <p:txBody>
+          <a:bodyPr wrap="square" rtlCol="0">
+            <a:spAutoFit/>
+          </a:bodyPr>
+          <a:lstStyle/>
+          <a:p>
+            <a:pPr algn="ctr"/>
+            <a:r>
+              <a:rPr lang="en-US" dirty="0"/>
+              <a:t>Door</a:t>
+            </a:r>
+          </a:p>
+        </p:txBody>
+      </p:sp>
+      <p:sp>
+        <p:nvSpPr>
+          <p:cNvPr id="2" name="TextBox 1">
+            <a:extLst>
+              <a:ext uri="{FF2B5EF4-FFF2-40B4-BE49-F238E27FC236}">
+                <a16:creationId xmlns:a16="http://schemas.microsoft.com/office/drawing/2014/main" id="{2976409D-004A-6FFE-91D0-82FE54236F39}"/>
+              </a:ext>
+            </a:extLst>
+          </p:cNvPr>
+          <p:cNvSpPr txBox="1"/>
+          <p:nvPr/>
+        </p:nvSpPr>
+        <p:spPr>
+          <a:xfrm>
+            <a:off x="862584" y="3346179"/>
+            <a:ext cx="1298448" cy="369332"/>
+          </a:xfrm>
+          <a:prstGeom prst="rect">
+            <a:avLst/>
+          </a:prstGeom>
+          <a:noFill/>
+        </p:spPr>
+        <p:txBody>
+          <a:bodyPr wrap="square" rtlCol="0">
+            <a:spAutoFit/>
+          </a:bodyPr>
+          <a:lstStyle/>
+          <a:p>
+            <a:pPr algn="ctr"/>
+            <a:r>
+              <a:rPr lang="en-US" dirty="0"/>
+              <a:t>Door</a:t>
+            </a:r>
+          </a:p>
+        </p:txBody>
+      </p:sp>
+      <p:sp>
+        <p:nvSpPr>
+          <p:cNvPr id="3" name="TextBox 2">
+            <a:extLst>
+              <a:ext uri="{FF2B5EF4-FFF2-40B4-BE49-F238E27FC236}">
+                <a16:creationId xmlns:a16="http://schemas.microsoft.com/office/drawing/2014/main" id="{BBAE1914-F34F-930B-D899-AB964B5CAE7F}"/>
+              </a:ext>
+            </a:extLst>
+          </p:cNvPr>
+          <p:cNvSpPr txBox="1"/>
+          <p:nvPr/>
+        </p:nvSpPr>
+        <p:spPr>
+          <a:xfrm>
+            <a:off x="10311384" y="3335512"/>
+            <a:ext cx="1298448" cy="369332"/>
+          </a:xfrm>
+          <a:prstGeom prst="rect">
+            <a:avLst/>
+          </a:prstGeom>
+          <a:noFill/>
+        </p:spPr>
+        <p:txBody>
+          <a:bodyPr wrap="square" rtlCol="0">
+            <a:spAutoFit/>
+          </a:bodyPr>
+          <a:lstStyle/>
+          <a:p>
+            <a:pPr algn="ctr"/>
+            <a:r>
+              <a:rPr lang="en-US" dirty="0"/>
+              <a:t>Door</a:t>
+            </a:r>
+          </a:p>
+        </p:txBody>
+      </p:sp>
+      <p:sp>
+        <p:nvSpPr>
+          <p:cNvPr id="4" name="TextBox 3">
+            <a:extLst>
+              <a:ext uri="{FF2B5EF4-FFF2-40B4-BE49-F238E27FC236}">
+                <a16:creationId xmlns:a16="http://schemas.microsoft.com/office/drawing/2014/main" id="{3C35C270-A42E-3EDB-5AB5-353DD0709979}"/>
+              </a:ext>
+            </a:extLst>
+          </p:cNvPr>
+          <p:cNvSpPr txBox="1"/>
+          <p:nvPr/>
+        </p:nvSpPr>
+        <p:spPr>
+          <a:xfrm>
+            <a:off x="5033772" y="4188133"/>
+            <a:ext cx="2404872" cy="538609"/>
+          </a:xfrm>
+          <a:prstGeom prst="rect">
+            <a:avLst/>
+          </a:prstGeom>
+          <a:noFill/>
+        </p:spPr>
+        <p:txBody>
+          <a:bodyPr wrap="square" rtlCol="0">
+            <a:spAutoFit/>
+          </a:bodyPr>
+          <a:lstStyle/>
+          <a:p>
+            <a:pPr algn="ctr"/>
+            <a:r>
+              <a:rPr lang="en-US" dirty="0"/>
+              <a:t>Sandbag Wall:</a:t>
+            </a:r>
+          </a:p>
+          <a:p>
+            <a:pPr algn="ctr"/>
+            <a:r>
+              <a:rPr lang="en-US" sz="1100" dirty="0"/>
+              <a:t>Ringed, Sandbags</a:t>
+            </a:r>
+          </a:p>
+        </p:txBody>
+      </p:sp>
+      <p:sp>
+        <p:nvSpPr>
+          <p:cNvPr id="9" name="TextBox 8">
+            <a:extLst>
+              <a:ext uri="{FF2B5EF4-FFF2-40B4-BE49-F238E27FC236}">
+                <a16:creationId xmlns:a16="http://schemas.microsoft.com/office/drawing/2014/main" id="{11A0C581-9DAC-F2B3-56AE-D6760A585ACD}"/>
+              </a:ext>
+            </a:extLst>
+          </p:cNvPr>
+          <p:cNvSpPr txBox="1"/>
+          <p:nvPr/>
+        </p:nvSpPr>
+        <p:spPr>
+          <a:xfrm>
+            <a:off x="5033772" y="2341046"/>
+            <a:ext cx="2404872" cy="538609"/>
+          </a:xfrm>
+          <a:prstGeom prst="rect">
+            <a:avLst/>
+          </a:prstGeom>
+          <a:noFill/>
+        </p:spPr>
+        <p:txBody>
+          <a:bodyPr wrap="square" rtlCol="0">
+            <a:spAutoFit/>
+          </a:bodyPr>
+          <a:lstStyle/>
+          <a:p>
+            <a:pPr algn="ctr"/>
+            <a:r>
+              <a:rPr lang="en-US" dirty="0"/>
+              <a:t>Sandbag Wall:</a:t>
+            </a:r>
+          </a:p>
+          <a:p>
+            <a:pPr algn="ctr"/>
+            <a:r>
+              <a:rPr lang="en-US" sz="1100" dirty="0"/>
+              <a:t>Ringed, Sandbags</a:t>
+            </a:r>
+          </a:p>
+        </p:txBody>
+      </p:sp>
+      <p:sp>
+        <p:nvSpPr>
+          <p:cNvPr id="10" name="TextBox 9">
+            <a:extLst>
+              <a:ext uri="{FF2B5EF4-FFF2-40B4-BE49-F238E27FC236}">
+                <a16:creationId xmlns:a16="http://schemas.microsoft.com/office/drawing/2014/main" id="{78945D43-055D-EDF9-3E68-6813FE64595D}"/>
+              </a:ext>
+            </a:extLst>
+          </p:cNvPr>
+          <p:cNvSpPr txBox="1"/>
+          <p:nvPr/>
+        </p:nvSpPr>
+        <p:spPr>
+          <a:xfrm>
+            <a:off x="2013204" y="5145205"/>
+            <a:ext cx="2404872" cy="538609"/>
+          </a:xfrm>
+          <a:prstGeom prst="rect">
+            <a:avLst/>
+          </a:prstGeom>
+          <a:noFill/>
+        </p:spPr>
+        <p:txBody>
+          <a:bodyPr wrap="square" rtlCol="0">
+            <a:spAutoFit/>
+          </a:bodyPr>
+          <a:lstStyle/>
+          <a:p>
+            <a:pPr algn="ctr"/>
+            <a:r>
+              <a:rPr lang="en-US" dirty="0"/>
+              <a:t>Sandbag Wall:</a:t>
+            </a:r>
+          </a:p>
+          <a:p>
+            <a:pPr algn="ctr"/>
+            <a:r>
+              <a:rPr lang="en-US" sz="1100" dirty="0"/>
+              <a:t>Ringed, Sandbags</a:t>
+            </a:r>
+          </a:p>
+        </p:txBody>
+      </p:sp>
+      <p:sp>
+        <p:nvSpPr>
+          <p:cNvPr id="11" name="TextBox 10">
+            <a:extLst>
+              <a:ext uri="{FF2B5EF4-FFF2-40B4-BE49-F238E27FC236}">
+                <a16:creationId xmlns:a16="http://schemas.microsoft.com/office/drawing/2014/main" id="{5E13FFBE-DBF9-F126-2CDD-B2E85E807586}"/>
+              </a:ext>
+            </a:extLst>
+          </p:cNvPr>
+          <p:cNvSpPr txBox="1"/>
+          <p:nvPr/>
+        </p:nvSpPr>
+        <p:spPr>
+          <a:xfrm>
+            <a:off x="7830312" y="1377877"/>
+            <a:ext cx="2404872" cy="538609"/>
+          </a:xfrm>
+          <a:prstGeom prst="rect">
+            <a:avLst/>
+          </a:prstGeom>
+          <a:noFill/>
+        </p:spPr>
+        <p:txBody>
+          <a:bodyPr wrap="square" rtlCol="0">
+            <a:spAutoFit/>
+          </a:bodyPr>
+          <a:lstStyle/>
+          <a:p>
+            <a:pPr algn="ctr"/>
+            <a:r>
+              <a:rPr lang="en-US" dirty="0"/>
+              <a:t>Sandbag Wall:</a:t>
+            </a:r>
+          </a:p>
+          <a:p>
+            <a:pPr algn="ctr"/>
+            <a:r>
+              <a:rPr lang="en-US" sz="1100" dirty="0"/>
+              <a:t>Ringed, Sandbags</a:t>
+            </a:r>
+          </a:p>
+        </p:txBody>
+      </p:sp>
+      <p:sp>
+        <p:nvSpPr>
+          <p:cNvPr id="12" name="TextBox 11">
+            <a:extLst>
+              <a:ext uri="{FF2B5EF4-FFF2-40B4-BE49-F238E27FC236}">
+                <a16:creationId xmlns:a16="http://schemas.microsoft.com/office/drawing/2014/main" id="{3C56F00C-164D-8A02-2041-B48CBA13D08E}"/>
+              </a:ext>
+            </a:extLst>
+          </p:cNvPr>
+          <p:cNvSpPr txBox="1"/>
+          <p:nvPr/>
+        </p:nvSpPr>
+        <p:spPr>
+          <a:xfrm>
+            <a:off x="2040636" y="1377877"/>
+            <a:ext cx="2404872" cy="538609"/>
+          </a:xfrm>
+          <a:prstGeom prst="rect">
+            <a:avLst/>
+          </a:prstGeom>
+          <a:noFill/>
+        </p:spPr>
+        <p:txBody>
+          <a:bodyPr wrap="square" rtlCol="0">
+            <a:spAutoFit/>
+          </a:bodyPr>
+          <a:lstStyle/>
+          <a:p>
+            <a:pPr algn="ctr"/>
+            <a:r>
+              <a:rPr lang="en-US" dirty="0"/>
+              <a:t>Sandbag Wall:</a:t>
+            </a:r>
+          </a:p>
+          <a:p>
+            <a:pPr algn="ctr"/>
+            <a:r>
+              <a:rPr lang="en-US" sz="1100" dirty="0"/>
+              <a:t>Ringed, Sandbags</a:t>
+            </a:r>
+          </a:p>
+        </p:txBody>
+      </p:sp>
+      <p:sp>
+        <p:nvSpPr>
+          <p:cNvPr id="13" name="TextBox 12">
+            <a:extLst>
+              <a:ext uri="{FF2B5EF4-FFF2-40B4-BE49-F238E27FC236}">
+                <a16:creationId xmlns:a16="http://schemas.microsoft.com/office/drawing/2014/main" id="{D8B10CBE-5291-EAE2-8F8B-43BBA2361908}"/>
+              </a:ext>
+            </a:extLst>
+          </p:cNvPr>
+          <p:cNvSpPr txBox="1"/>
+          <p:nvPr/>
+        </p:nvSpPr>
+        <p:spPr>
+          <a:xfrm>
+            <a:off x="7830312" y="5145204"/>
+            <a:ext cx="2404872" cy="538609"/>
+          </a:xfrm>
+          <a:prstGeom prst="rect">
+            <a:avLst/>
+          </a:prstGeom>
+          <a:noFill/>
+        </p:spPr>
+        <p:txBody>
+          <a:bodyPr wrap="square" rtlCol="0">
+            <a:spAutoFit/>
+          </a:bodyPr>
+          <a:lstStyle/>
+          <a:p>
+            <a:pPr algn="ctr"/>
+            <a:r>
+              <a:rPr lang="en-US" dirty="0"/>
+              <a:t>Sandbag Wall:</a:t>
+            </a:r>
+          </a:p>
+          <a:p>
+            <a:pPr algn="ctr"/>
+            <a:r>
+              <a:rPr lang="en-US" sz="1100" dirty="0"/>
+              <a:t>Ringed, Sandbags</a:t>
+            </a:r>
+          </a:p>
+        </p:txBody>
+      </p:sp>
+      <p:sp>
+        <p:nvSpPr>
+          <p:cNvPr id="14" name="Oval 13">
+            <a:extLst>
+              <a:ext uri="{FF2B5EF4-FFF2-40B4-BE49-F238E27FC236}">
+                <a16:creationId xmlns:a16="http://schemas.microsoft.com/office/drawing/2014/main" id="{0639D24C-B40C-8223-848B-E601E5D066A6}"/>
+              </a:ext>
+            </a:extLst>
+          </p:cNvPr>
+          <p:cNvSpPr/>
+          <p:nvPr/>
+        </p:nvSpPr>
+        <p:spPr>
+          <a:xfrm>
+            <a:off x="9168384" y="5308909"/>
+            <a:ext cx="417576" cy="374904"/>
+          </a:xfrm>
+          <a:prstGeom prst="ellipse">
+            <a:avLst/>
+          </a:prstGeom>
+        </p:spPr>
+        <p:style>
+          <a:lnRef idx="2">
+            <a:schemeClr val="accent1">
+              <a:shade val="15000"/>
+            </a:schemeClr>
+          </a:lnRef>
+          <a:fillRef idx="1">
+            <a:schemeClr val="accent1"/>
+          </a:fillRef>
+          <a:effectRef idx="0">
+            <a:schemeClr val="accent1"/>
+          </a:effectRef>
+          <a:fontRef idx="minor">
+            <a:schemeClr val="lt1"/>
+          </a:fontRef>
+        </p:style>
+        <p:txBody>
+          <a:bodyPr rtlCol="0" anchor="ctr"/>
+          <a:lstStyle/>
+          <a:p>
+            <a:pPr algn="ctr"/>
+            <a:r>
+              <a:rPr lang="en-US" dirty="0"/>
+              <a:t>P</a:t>
+            </a:r>
+          </a:p>
+        </p:txBody>
+      </p:sp>
+      <p:sp>
+        <p:nvSpPr>
+          <p:cNvPr id="15" name="Oval 14">
+            <a:extLst>
+              <a:ext uri="{FF2B5EF4-FFF2-40B4-BE49-F238E27FC236}">
+                <a16:creationId xmlns:a16="http://schemas.microsoft.com/office/drawing/2014/main" id="{9F73F35D-461F-6BF4-EB7E-59DE8581A516}"/>
+              </a:ext>
+            </a:extLst>
+          </p:cNvPr>
+          <p:cNvSpPr/>
+          <p:nvPr/>
+        </p:nvSpPr>
+        <p:spPr>
+          <a:xfrm>
+            <a:off x="3006852" y="1374384"/>
+            <a:ext cx="417576" cy="374904"/>
+          </a:xfrm>
+          <a:prstGeom prst="ellipse">
+            <a:avLst/>
+          </a:prstGeom>
+        </p:spPr>
+        <p:style>
+          <a:lnRef idx="2">
+            <a:schemeClr val="accent2">
+              <a:shade val="15000"/>
+            </a:schemeClr>
+          </a:lnRef>
+          <a:fillRef idx="1">
+            <a:schemeClr val="accent2"/>
+          </a:fillRef>
+          <a:effectRef idx="0">
+            <a:schemeClr val="accent2"/>
+          </a:effectRef>
+          <a:fontRef idx="minor">
+            <a:schemeClr val="lt1"/>
+          </a:fontRef>
+        </p:style>
+        <p:txBody>
+          <a:bodyPr rtlCol="0" anchor="ctr"/>
+          <a:lstStyle/>
+          <a:p>
+            <a:pPr algn="ctr"/>
+            <a:r>
+              <a:rPr lang="en-US" dirty="0"/>
+              <a:t>3</a:t>
+            </a:r>
+          </a:p>
+        </p:txBody>
+      </p:sp>
+      <p:sp>
+        <p:nvSpPr>
+          <p:cNvPr id="16" name="Oval 15">
+            <a:extLst>
+              <a:ext uri="{FF2B5EF4-FFF2-40B4-BE49-F238E27FC236}">
+                <a16:creationId xmlns:a16="http://schemas.microsoft.com/office/drawing/2014/main" id="{CE26F3DE-40C5-B43B-00FF-4E46BE919D5C}"/>
+              </a:ext>
+            </a:extLst>
+          </p:cNvPr>
+          <p:cNvSpPr/>
+          <p:nvPr/>
+        </p:nvSpPr>
+        <p:spPr>
+          <a:xfrm>
+            <a:off x="8959596" y="1459729"/>
+            <a:ext cx="417576" cy="374904"/>
+          </a:xfrm>
+          <a:prstGeom prst="ellipse">
+            <a:avLst/>
+          </a:prstGeom>
+        </p:spPr>
+        <p:style>
+          <a:lnRef idx="2">
+            <a:schemeClr val="accent2">
+              <a:shade val="15000"/>
+            </a:schemeClr>
+          </a:lnRef>
+          <a:fillRef idx="1">
+            <a:schemeClr val="accent2"/>
+          </a:fillRef>
+          <a:effectRef idx="0">
+            <a:schemeClr val="accent2"/>
+          </a:effectRef>
+          <a:fontRef idx="minor">
+            <a:schemeClr val="lt1"/>
+          </a:fontRef>
+        </p:style>
+        <p:txBody>
+          <a:bodyPr rtlCol="0" anchor="ctr"/>
+          <a:lstStyle/>
+          <a:p>
+            <a:pPr algn="ctr"/>
+            <a:r>
+              <a:rPr lang="en-US" dirty="0"/>
+              <a:t>1</a:t>
+            </a:r>
+          </a:p>
+        </p:txBody>
+      </p:sp>
+      <p:sp>
+        <p:nvSpPr>
+          <p:cNvPr id="17" name="Oval 16">
+            <a:extLst>
+              <a:ext uri="{FF2B5EF4-FFF2-40B4-BE49-F238E27FC236}">
+                <a16:creationId xmlns:a16="http://schemas.microsoft.com/office/drawing/2014/main" id="{BE678E0B-B34B-BE03-B639-5D25DC492740}"/>
+              </a:ext>
+            </a:extLst>
+          </p:cNvPr>
+          <p:cNvSpPr/>
+          <p:nvPr/>
+        </p:nvSpPr>
+        <p:spPr>
+          <a:xfrm>
+            <a:off x="8959596" y="371503"/>
+            <a:ext cx="417576" cy="374904"/>
+          </a:xfrm>
+          <a:prstGeom prst="ellipse">
+            <a:avLst/>
+          </a:prstGeom>
+        </p:spPr>
+        <p:style>
+          <a:lnRef idx="2">
+            <a:schemeClr val="accent2">
+              <a:shade val="15000"/>
+            </a:schemeClr>
+          </a:lnRef>
+          <a:fillRef idx="1">
+            <a:schemeClr val="accent2"/>
+          </a:fillRef>
+          <a:effectRef idx="0">
+            <a:schemeClr val="accent2"/>
+          </a:effectRef>
+          <a:fontRef idx="minor">
+            <a:schemeClr val="lt1"/>
+          </a:fontRef>
+        </p:style>
+        <p:txBody>
+          <a:bodyPr rtlCol="0" anchor="ctr"/>
+          <a:lstStyle/>
+          <a:p>
+            <a:pPr algn="ctr"/>
+            <a:r>
+              <a:rPr lang="en-US" dirty="0"/>
+              <a:t>2</a:t>
+            </a:r>
+          </a:p>
+        </p:txBody>
+      </p:sp>
+      <p:sp>
+        <p:nvSpPr>
+          <p:cNvPr id="18" name="TextBox 17">
+            <a:extLst>
+              <a:ext uri="{FF2B5EF4-FFF2-40B4-BE49-F238E27FC236}">
+                <a16:creationId xmlns:a16="http://schemas.microsoft.com/office/drawing/2014/main" id="{E30C2636-9A96-C933-769B-0BC02D21F56F}"/>
+              </a:ext>
+            </a:extLst>
+          </p:cNvPr>
+          <p:cNvSpPr txBox="1"/>
+          <p:nvPr/>
+        </p:nvSpPr>
+        <p:spPr>
+          <a:xfrm>
+            <a:off x="1042416" y="339237"/>
+            <a:ext cx="630936" cy="369332"/>
+          </a:xfrm>
+          <a:prstGeom prst="rect">
+            <a:avLst/>
+          </a:prstGeom>
+          <a:noFill/>
+        </p:spPr>
+        <p:txBody>
+          <a:bodyPr wrap="square" rtlCol="0">
+            <a:spAutoFit/>
+          </a:bodyPr>
+          <a:lstStyle/>
+          <a:p>
+            <a:r>
+              <a:rPr lang="en-US" dirty="0"/>
+              <a:t>1</a:t>
+            </a:r>
+          </a:p>
+        </p:txBody>
+      </p:sp>
+      <p:sp>
+        <p:nvSpPr>
+          <p:cNvPr id="19" name="TextBox 18">
+            <a:extLst>
+              <a:ext uri="{FF2B5EF4-FFF2-40B4-BE49-F238E27FC236}">
+                <a16:creationId xmlns:a16="http://schemas.microsoft.com/office/drawing/2014/main" id="{6C48BBA5-D82F-2178-BFEF-97BE157A250A}"/>
+              </a:ext>
+            </a:extLst>
+          </p:cNvPr>
+          <p:cNvSpPr txBox="1"/>
+          <p:nvPr/>
+        </p:nvSpPr>
+        <p:spPr>
+          <a:xfrm>
+            <a:off x="1042416" y="1289304"/>
+            <a:ext cx="560832" cy="369332"/>
+          </a:xfrm>
+          <a:prstGeom prst="rect">
+            <a:avLst/>
+          </a:prstGeom>
+          <a:noFill/>
+        </p:spPr>
+        <p:txBody>
+          <a:bodyPr wrap="square" rtlCol="0">
+            <a:spAutoFit/>
+          </a:bodyPr>
+          <a:lstStyle/>
+          <a:p>
+            <a:r>
+              <a:rPr lang="en-US" dirty="0"/>
+              <a:t>2</a:t>
+            </a:r>
+          </a:p>
+        </p:txBody>
+      </p:sp>
+      <p:sp>
+        <p:nvSpPr>
+          <p:cNvPr id="20" name="TextBox 19">
+            <a:extLst>
+              <a:ext uri="{FF2B5EF4-FFF2-40B4-BE49-F238E27FC236}">
+                <a16:creationId xmlns:a16="http://schemas.microsoft.com/office/drawing/2014/main" id="{626F9C72-1757-5781-31AC-424D1FF0E080}"/>
+              </a:ext>
+            </a:extLst>
+          </p:cNvPr>
+          <p:cNvSpPr txBox="1"/>
+          <p:nvPr/>
+        </p:nvSpPr>
+        <p:spPr>
+          <a:xfrm>
+            <a:off x="1042416" y="2341046"/>
+            <a:ext cx="438912" cy="369332"/>
+          </a:xfrm>
+          <a:prstGeom prst="rect">
+            <a:avLst/>
+          </a:prstGeom>
+          <a:noFill/>
+        </p:spPr>
+        <p:txBody>
+          <a:bodyPr wrap="square" rtlCol="0">
+            <a:spAutoFit/>
+          </a:bodyPr>
+          <a:lstStyle/>
+          <a:p>
+            <a:r>
+              <a:rPr lang="en-US" dirty="0"/>
+              <a:t>3</a:t>
+            </a:r>
+          </a:p>
+        </p:txBody>
+      </p:sp>
+      <p:sp>
+        <p:nvSpPr>
+          <p:cNvPr id="21" name="TextBox 20">
+            <a:extLst>
+              <a:ext uri="{FF2B5EF4-FFF2-40B4-BE49-F238E27FC236}">
+                <a16:creationId xmlns:a16="http://schemas.microsoft.com/office/drawing/2014/main" id="{6A72DCFA-F7C4-A3B1-5FC4-4C7ADA4CDA2F}"/>
+              </a:ext>
+            </a:extLst>
+          </p:cNvPr>
+          <p:cNvSpPr txBox="1"/>
+          <p:nvPr/>
+        </p:nvSpPr>
+        <p:spPr>
+          <a:xfrm>
+            <a:off x="862584" y="3172968"/>
+            <a:ext cx="1021080" cy="369332"/>
+          </a:xfrm>
+          <a:prstGeom prst="rect">
+            <a:avLst/>
+          </a:prstGeom>
+          <a:noFill/>
+        </p:spPr>
+        <p:txBody>
+          <a:bodyPr wrap="square" rtlCol="0">
+            <a:spAutoFit/>
+          </a:bodyPr>
+          <a:lstStyle/>
+          <a:p>
+            <a:r>
+              <a:rPr lang="en-US" dirty="0"/>
+              <a:t>4</a:t>
+            </a:r>
+          </a:p>
+        </p:txBody>
+      </p:sp>
+      <p:sp>
+        <p:nvSpPr>
+          <p:cNvPr id="22" name="TextBox 21">
+            <a:extLst>
+              <a:ext uri="{FF2B5EF4-FFF2-40B4-BE49-F238E27FC236}">
+                <a16:creationId xmlns:a16="http://schemas.microsoft.com/office/drawing/2014/main" id="{EE99525C-5BF2-AA0F-EEB0-785516F83F82}"/>
+              </a:ext>
+            </a:extLst>
+          </p:cNvPr>
+          <p:cNvSpPr txBox="1"/>
+          <p:nvPr/>
+        </p:nvSpPr>
+        <p:spPr>
+          <a:xfrm>
+            <a:off x="795528" y="4315968"/>
+            <a:ext cx="877824" cy="369332"/>
+          </a:xfrm>
+          <a:prstGeom prst="rect">
+            <a:avLst/>
+          </a:prstGeom>
+          <a:noFill/>
+        </p:spPr>
+        <p:txBody>
+          <a:bodyPr wrap="square" rtlCol="0">
+            <a:spAutoFit/>
+          </a:bodyPr>
+          <a:lstStyle/>
+          <a:p>
+            <a:r>
+              <a:rPr lang="en-US" dirty="0"/>
+              <a:t>5</a:t>
+            </a:r>
+          </a:p>
+        </p:txBody>
+      </p:sp>
+      <p:sp>
+        <p:nvSpPr>
+          <p:cNvPr id="23" name="TextBox 22">
+            <a:extLst>
+              <a:ext uri="{FF2B5EF4-FFF2-40B4-BE49-F238E27FC236}">
+                <a16:creationId xmlns:a16="http://schemas.microsoft.com/office/drawing/2014/main" id="{51538C2B-AFD7-8419-EF2C-CDA334E75431}"/>
+              </a:ext>
+            </a:extLst>
+          </p:cNvPr>
+          <p:cNvSpPr txBox="1"/>
+          <p:nvPr/>
+        </p:nvSpPr>
+        <p:spPr>
+          <a:xfrm>
+            <a:off x="1179576" y="5145204"/>
+            <a:ext cx="704088" cy="369332"/>
+          </a:xfrm>
+          <a:prstGeom prst="rect">
+            <a:avLst/>
+          </a:prstGeom>
+          <a:noFill/>
+        </p:spPr>
+        <p:txBody>
+          <a:bodyPr wrap="square" rtlCol="0">
+            <a:spAutoFit/>
+          </a:bodyPr>
+          <a:lstStyle/>
+          <a:p>
+            <a:r>
+              <a:rPr lang="en-US" dirty="0"/>
+              <a:t>6</a:t>
+            </a:r>
+          </a:p>
+        </p:txBody>
+      </p:sp>
+      <p:sp>
+        <p:nvSpPr>
+          <p:cNvPr id="24" name="TextBox 23">
+            <a:extLst>
+              <a:ext uri="{FF2B5EF4-FFF2-40B4-BE49-F238E27FC236}">
+                <a16:creationId xmlns:a16="http://schemas.microsoft.com/office/drawing/2014/main" id="{6A621CE2-40C3-5C83-BB4A-83092C8328D6}"/>
+              </a:ext>
+            </a:extLst>
+          </p:cNvPr>
+          <p:cNvSpPr txBox="1"/>
+          <p:nvPr/>
+        </p:nvSpPr>
+        <p:spPr>
+          <a:xfrm>
+            <a:off x="1179576" y="6044184"/>
+            <a:ext cx="493776" cy="369332"/>
+          </a:xfrm>
+          <a:prstGeom prst="rect">
+            <a:avLst/>
+          </a:prstGeom>
+          <a:noFill/>
+        </p:spPr>
+        <p:txBody>
+          <a:bodyPr wrap="square" rtlCol="0">
+            <a:spAutoFit/>
+          </a:bodyPr>
+          <a:lstStyle/>
+          <a:p>
+            <a:r>
+              <a:rPr lang="en-US"/>
+              <a:t>7</a:t>
+            </a:r>
+          </a:p>
+        </p:txBody>
+      </p:sp>
+    </p:spTree>
+    <p:extLst>
+      <p:ext uri="{BB962C8B-B14F-4D97-AF65-F5344CB8AC3E}">
+        <p14:creationId xmlns:p14="http://schemas.microsoft.com/office/powerpoint/2010/main" val="3046014949"/>
+      </p:ext>
+    </p:extLst>
+  </p:cSld>
+  <p:clrMapOvr>
+    <a:masterClrMapping/>
+  </p:clrMapOvr>
+</p:sld>
+</file>
+
+<file path=ppt/slides/slide4.xml><?xml version="1.0" encoding="utf-8"?>
 <p:sld xmlns:a="http://schemas.openxmlformats.org/drawingml/2006/main" xmlns:r="http://schemas.openxmlformats.org/officeDocument/2006/relationships" xmlns:p="http://schemas.openxmlformats.org/presentationml/2006/main">
   <p:cSld>
     <p:spTree>

</xml_diff>